<commit_message>
chore: update presentation assets and remove obsolete progress report files
</commit_message>
<xml_diff>
--- a/Milestone1_Presentation.pptx
+++ b/Milestone1_Presentation.pptx
@@ -4,6 +4,9 @@
   <p:sldMasterIdLst>
     <p:sldMasterId id="2147483648" r:id="rId1"/>
   </p:sldMasterIdLst>
+  <p:notesMasterIdLst>
+    <p:notesMasterId r:id="rId10"/>
+  </p:notesMasterIdLst>
   <p:sldIdLst>
     <p:sldId id="256" r:id="rId2"/>
     <p:sldId id="257" r:id="rId3"/>
@@ -14,10 +17,7 @@
     <p:sldId id="262" r:id="rId8"/>
     <p:sldId id="263" r:id="rId9"/>
   </p:sldIdLst>
-  <p:notesMasterIdLst>
-    <p:notesMasterId r:id="rId10"/>
-  </p:notesMasterIdLst>
-  <p:sldSz cx="9144000" cy="5143500"/>
+  <p:sldSz cx="9144000" cy="5143500" type="screen16x9"/>
   <p:notesSz cx="5143500" cy="9144000"/>
   <p:defaultTextStyle>
     <a:lvl1pPr marL="0" algn="l" defTabSz="914400" rtl="0" eaLnBrk="1" latinLnBrk="0" hangingPunct="1">
@@ -111,6 +111,11 @@
       </a:defRPr>
     </a:lvl9pPr>
   </p:defaultTextStyle>
+  <p:extLst>
+    <p:ext uri="{EFAFB233-063F-42B5-8137-9DF3F51BA10A}">
+      <p15:sldGuideLst xmlns:p15="http://schemas.microsoft.com/office/powerpoint/2012/main"/>
+    </p:ext>
+  </p:extLst>
 </p:presentation>
 </file>
 
@@ -136,234 +141,10 @@
           <a:chExt cx="0" cy="0"/>
         </a:xfrm>
       </p:grpSpPr>
-      <p:sp>
-        <p:nvSpPr>
-          <p:cNvPr id="2" name="Header Placeholder 1"/>
-          <p:cNvSpPr>
-            <a:spLocks noGrp="1"/>
-          </p:cNvSpPr>
-          <p:nvPr>
-            <p:ph type="hdr" sz="quarter"/>
-          </p:nvPr>
-        </p:nvSpPr>
-        <p:spPr>
-          <a:xfrm>
-            <a:off x="0" y="0"/>
-            <a:ext cx="2971800" cy="458788"/>
-          </a:xfrm>
-          <a:prstGeom prst="rect">
-            <a:avLst/>
-          </a:prstGeom>
-        </p:spPr>
-        <p:txBody>
-          <a:bodyPr vert="horz" lIns="91440" tIns="45720" rIns="91440" bIns="45720" rtlCol="0"/>
-          <a:lstStyle>
-            <a:lvl1pPr algn="l">
-              <a:defRPr sz="1200"/>
-            </a:lvl1pPr>
-          </a:lstStyle>
-          <a:p>
-            <a:endParaRPr lang="en-US"/>
-          </a:p>
-        </p:txBody>
-      </p:sp>
-      <p:sp>
-        <p:nvSpPr>
-          <p:cNvPr id="3" name="Date Placeholder 2"/>
-          <p:cNvSpPr>
-            <a:spLocks noGrp="1"/>
-          </p:cNvSpPr>
-          <p:nvPr>
-            <p:ph type="dt" idx="1"/>
-          </p:nvPr>
-        </p:nvSpPr>
-        <p:spPr>
-          <a:xfrm>
-            <a:off x="3884613" y="0"/>
-            <a:ext cx="2971800" cy="458788"/>
-          </a:xfrm>
-          <a:prstGeom prst="rect">
-            <a:avLst/>
-          </a:prstGeom>
-        </p:spPr>
-        <p:txBody>
-          <a:bodyPr vert="horz" lIns="91440" tIns="45720" rIns="91440" bIns="45720" rtlCol="0"/>
-          <a:lstStyle>
-            <a:lvl1pPr algn="r">
-              <a:defRPr sz="1200"/>
-            </a:lvl1pPr>
-          </a:lstStyle>
-          <a:p>
-            <a:fld id="{5282F153-3F37-0F45-9E97-73ACFA13230C}" type="datetimeFigureOut">
-              <a:rPr lang="en-US"/>
-              <a:t>7/23/19</a:t>
-            </a:fld>
-            <a:endParaRPr lang="en-US"/>
-          </a:p>
-        </p:txBody>
-      </p:sp>
-      <p:sp>
-        <p:nvSpPr>
-          <p:cNvPr id="4" name="Slide Image Placeholder 3"/>
-          <p:cNvSpPr>
-            <a:spLocks noGrp="1" noRot="1" noChangeAspect="1"/>
-          </p:cNvSpPr>
-          <p:nvPr>
-            <p:ph type="sldImg" idx="2"/>
-          </p:nvPr>
-        </p:nvSpPr>
-        <p:spPr>
-          <a:xfrm>
-            <a:off x="685800" y="1143000"/>
-            <a:ext cx="5486400" cy="3086100"/>
-          </a:xfrm>
-          <a:prstGeom prst="rect">
-            <a:avLst/>
-          </a:prstGeom>
-          <a:noFill/>
-          <a:ln w="12700">
-            <a:solidFill>
-              <a:prstClr val="black"/>
-            </a:solidFill>
-          </a:ln>
-        </p:spPr>
-        <p:txBody>
-          <a:bodyPr vert="horz" lIns="91440" tIns="45720" rIns="91440" bIns="45720" rtlCol="0" anchor="ctr"/>
-          <a:lstStyle/>
-          <a:p>
-            <a:endParaRPr lang="en-US"/>
-          </a:p>
-        </p:txBody>
-      </p:sp>
-      <p:sp>
-        <p:nvSpPr>
-          <p:cNvPr id="5" name="Notes Placeholder 4"/>
-          <p:cNvSpPr>
-            <a:spLocks noGrp="1"/>
-          </p:cNvSpPr>
-          <p:nvPr>
-            <p:ph type="body" sz="quarter" idx="3"/>
-          </p:nvPr>
-        </p:nvSpPr>
-        <p:spPr>
-          <a:xfrm>
-            <a:off x="685800" y="4400550"/>
-            <a:ext cx="5486400" cy="3600450"/>
-          </a:xfrm>
-          <a:prstGeom prst="rect">
-            <a:avLst/>
-          </a:prstGeom>
-        </p:spPr>
-        <p:txBody>
-          <a:bodyPr vert="horz" lIns="91440" tIns="45720" rIns="91440" bIns="45720" rtlCol="0"/>
-          <a:lstStyle/>
-          <a:p>
-            <a:pPr lvl="0"/>
-            <a:r>
-              <a:rPr lang="en-US"/>
-              <a:t>Click to edit Master text styles</a:t>
-            </a:r>
-          </a:p>
-          <a:p>
-            <a:pPr lvl="1"/>
-            <a:r>
-              <a:rPr lang="en-US"/>
-              <a:t>Second level</a:t>
-            </a:r>
-          </a:p>
-          <a:p>
-            <a:pPr lvl="2"/>
-            <a:r>
-              <a:rPr lang="en-US"/>
-              <a:t>Third level</a:t>
-            </a:r>
-          </a:p>
-          <a:p>
-            <a:pPr lvl="3"/>
-            <a:r>
-              <a:rPr lang="en-US"/>
-              <a:t>Fourth level</a:t>
-            </a:r>
-          </a:p>
-          <a:p>
-            <a:pPr lvl="4"/>
-            <a:r>
-              <a:rPr lang="en-US"/>
-              <a:t>Fifth level</a:t>
-            </a:r>
-          </a:p>
-        </p:txBody>
-      </p:sp>
-      <p:sp>
-        <p:nvSpPr>
-          <p:cNvPr id="6" name="Footer Placeholder 5"/>
-          <p:cNvSpPr>
-            <a:spLocks noGrp="1"/>
-          </p:cNvSpPr>
-          <p:nvPr>
-            <p:ph type="ftr" sz="quarter" idx="4"/>
-          </p:nvPr>
-        </p:nvSpPr>
-        <p:spPr>
-          <a:xfrm>
-            <a:off x="0" y="8685213"/>
-            <a:ext cx="2971800" cy="458787"/>
-          </a:xfrm>
-          <a:prstGeom prst="rect">
-            <a:avLst/>
-          </a:prstGeom>
-        </p:spPr>
-        <p:txBody>
-          <a:bodyPr vert="horz" lIns="91440" tIns="45720" rIns="91440" bIns="45720" rtlCol="0" anchor="b"/>
-          <a:lstStyle>
-            <a:lvl1pPr algn="l">
-              <a:defRPr sz="1200"/>
-            </a:lvl1pPr>
-          </a:lstStyle>
-          <a:p>
-            <a:endParaRPr lang="en-US"/>
-          </a:p>
-        </p:txBody>
-      </p:sp>
-      <p:sp>
-        <p:nvSpPr>
-          <p:cNvPr id="7" name="Slide Number Placeholder 6"/>
-          <p:cNvSpPr>
-            <a:spLocks noGrp="1"/>
-          </p:cNvSpPr>
-          <p:nvPr>
-            <p:ph type="sldNum" sz="quarter" idx="5"/>
-          </p:nvPr>
-        </p:nvSpPr>
-        <p:spPr>
-          <a:xfrm>
-            <a:off x="3884613" y="8685213"/>
-            <a:ext cx="2971800" cy="458787"/>
-          </a:xfrm>
-          <a:prstGeom prst="rect">
-            <a:avLst/>
-          </a:prstGeom>
-        </p:spPr>
-        <p:txBody>
-          <a:bodyPr vert="horz" lIns="91440" tIns="45720" rIns="91440" bIns="45720" rtlCol="0" anchor="b"/>
-          <a:lstStyle>
-            <a:lvl1pPr algn="r">
-              <a:defRPr sz="1200"/>
-            </a:lvl1pPr>
-          </a:lstStyle>
-          <a:p>
-            <a:fld id="{CE5E9CC1-C706-0F49-92D6-E571CC5EEA8F}" type="slidenum">
-              <a:rPr lang="en-US"/>
-              <a:t>‹#›</a:t>
-            </a:fld>
-            <a:endParaRPr lang="en-US"/>
-          </a:p>
-        </p:txBody>
-      </p:sp>
     </p:spTree>
     <p:extLst>
       <p:ext uri="{BB962C8B-B14F-4D97-AF65-F5344CB8AC3E}">
-        <p14:creationId xmlns:p14="http://schemas.microsoft.com/office/powerpoint/2010/main" val="1024086991"/>
+        <p14:creationId xmlns:p14="http://schemas.microsoft.com/office/powerpoint/2010/main" val="3137579717"/>
       </p:ext>
     </p:extLst>
   </p:cSld>
@@ -511,7 +292,6 @@
               <a:rPr lang="en-US" dirty="0"/>
               <a:t>Milestone 1: foundation. We chose Architecture A (Distributed Ticket Booking) and instantiated it as a vaccine-slot booking system.</a:t>
             </a:r>
-            <a:endParaRPr lang="en-US" dirty="0"/>
           </a:p>
         </p:txBody>
       </p:sp>
@@ -599,7 +379,6 @@
               <a:rPr lang="en-US" dirty="0"/>
               <a:t>Maps one-to-one to the Milestone 1 objectives and deliverables in the assignment PDF.</a:t>
             </a:r>
-            <a:endParaRPr lang="en-US" dirty="0"/>
           </a:p>
         </p:txBody>
       </p:sp>
@@ -687,7 +466,6 @@
               <a:rPr lang="en-US" dirty="0"/>
               <a:t>The LLM runs on a separate server as the assignment requires. The app server never loads the model; it calls LLMService over gRPC.</a:t>
             </a:r>
-            <a:endParaRPr lang="en-US" dirty="0"/>
           </a:p>
         </p:txBody>
       </p:sp>
@@ -775,7 +553,6 @@
               <a:rPr lang="en-US" dirty="0"/>
               <a:t>Function signatures follow the assignment; minor changes are allowed. Note: authentication is a stub in M1 (any non-empty password is accepted); real credential checks are future work.</a:t>
             </a:r>
-            <a:endParaRPr lang="en-US" dirty="0"/>
           </a:p>
         </p:txBody>
       </p:sp>
@@ -863,7 +640,6 @@
               <a:rPr lang="en-US" dirty="0"/>
               <a:t>Run of scripts/demo_concurrency.py: 10 threads, slot with 3 available. Result: 3 accepted, 7 rejected, remaining 0, finished in about 12 ms on our machine.</a:t>
             </a:r>
-            <a:endParaRPr lang="en-US" dirty="0"/>
           </a:p>
         </p:txBody>
       </p:sp>
@@ -951,7 +727,6 @@
               <a:rPr lang="en-US" dirty="0"/>
               <a:t>Sample queries come from scripts/client_demo.py. Answers are excerpts of real Qwen2.5-0.5B output from our live run (about 12 s per answer on a MacBook CPU). A 0.5B model sometimes drifts from the system-prompt rules, e.g. it invented a medical-certificate requirement; larger or fine-tuned models are future work.</a:t>
             </a:r>
-            <a:endParaRPr lang="en-US" dirty="0"/>
           </a:p>
         </p:txBody>
       </p:sp>
@@ -1039,7 +814,6 @@
               <a:rPr lang="en-US" dirty="0"/>
               <a:t>Screenshot from our own machine on 29 Sep 2026. LLM answers took roughly 12 seconds each on CPU; the booking race finished in 12 ms.</a:t>
             </a:r>
-            <a:endParaRPr lang="en-US" dirty="0"/>
           </a:p>
         </p:txBody>
       </p:sp>
@@ -1127,7 +901,6 @@
               <a:rPr lang="en-US" dirty="0"/>
               <a:t>Tests: 13 unit tests pass without a server; 2 integration tests pass against live servers. Known M1 gaps: mock authentication, in-memory state, single app server.</a:t>
             </a:r>
-            <a:endParaRPr lang="en-US" dirty="0"/>
           </a:p>
         </p:txBody>
       </p:sp>
@@ -1200,6 +973,11 @@
 <file path=ppt/slideMasters/slideMaster1.xml><?xml version="1.0" encoding="utf-8"?>
 <p:sldMaster xmlns:a="http://schemas.openxmlformats.org/drawingml/2006/main" xmlns:r="http://schemas.openxmlformats.org/officeDocument/2006/relationships" xmlns:p="http://schemas.openxmlformats.org/presentationml/2006/main">
   <p:cSld>
+    <p:bg>
+      <p:bgRef idx="1001">
+        <a:schemeClr val="bg1"/>
+      </p:bgRef>
+    </p:bg>
     <p:spTree>
       <p:nvGrpSpPr>
         <p:cNvPr id="1" name=""/>
@@ -1482,6 +1260,7 @@
         <a:solidFill>
           <a:srgbClr val="0E2A36"/>
         </a:solidFill>
+        <a:effectLst/>
       </p:bgPr>
     </p:bg>
     <p:spTree>
@@ -1519,11 +1298,11 @@
           <a:bodyPr wrap="square" lIns="0" tIns="0" rIns="0" bIns="0" rtlCol="0" anchor="t"/>
           <a:lstStyle/>
           <a:p>
-            <a:pPr indent="0" marL="0">
-              <a:buNone/>
-            </a:pPr>
-            <a:r>
-              <a:rPr lang="en-US" sz="1200" b="1" spc="200" kern="0" dirty="0">
+            <a:pPr marL="0" indent="0">
+              <a:buNone/>
+            </a:pPr>
+            <a:r>
+              <a:rPr lang="en-US" sz="1200" b="1" kern="0" spc="200" dirty="0">
                 <a:solidFill>
                   <a:srgbClr val="F2A541"/>
                 </a:solidFill>
@@ -1558,7 +1337,7 @@
           <a:bodyPr wrap="square" lIns="0" tIns="0" rIns="0" bIns="0" rtlCol="0" anchor="t"/>
           <a:lstStyle/>
           <a:p>
-            <a:pPr indent="0" marL="0">
+            <a:pPr marL="0" indent="0">
               <a:buNone/>
             </a:pPr>
             <a:r>
@@ -1597,7 +1376,7 @@
           <a:bodyPr wrap="square" lIns="0" tIns="0" rIns="0" bIns="0" rtlCol="0" anchor="t"/>
           <a:lstStyle/>
           <a:p>
-            <a:pPr indent="0" marL="0">
+            <a:pPr marL="0" indent="0">
               <a:buNone/>
             </a:pPr>
             <a:r>
@@ -1636,7 +1415,7 @@
           <a:bodyPr wrap="square" lIns="0" tIns="0" rIns="0" bIns="0" rtlCol="0" anchor="t"/>
           <a:lstStyle/>
           <a:p>
-            <a:pPr indent="0" marL="0">
+            <a:pPr marL="0" indent="0">
               <a:buNone/>
             </a:pPr>
             <a:r>
@@ -1648,12 +1427,11 @@
                 <a:ea typeface="Calibri" pitchFamily="34" charset="-122"/>
                 <a:cs typeface="Calibri" pitchFamily="34" charset="-120"/>
               </a:rPr>
-              <a:t>Vaccine-slot booking on Architecture A</a:t>
-            </a:r>
-            <a:endParaRPr lang="en-US" sz="1300" dirty="0"/>
-          </a:p>
-          <a:p>
-            <a:pPr indent="0" marL="0">
+              <a:t>Ticket Booking for Vaccine-Slot </a:t>
+            </a:r>
+          </a:p>
+          <a:p>
+            <a:pPr marL="0" indent="0">
               <a:buNone/>
             </a:pPr>
             <a:r>
@@ -1666,6 +1444,55 @@
                 <a:cs typeface="Calibri" pitchFamily="34" charset="-120"/>
               </a:rPr>
               <a:t>Team AOS · BITS Pilani · Semester I 2026–27</a:t>
+            </a:r>
+          </a:p>
+          <a:p>
+            <a:pPr marL="0" indent="0">
+              <a:buNone/>
+            </a:pPr>
+            <a:r>
+              <a:rPr lang="en-US" sz="1300" dirty="0" err="1">
+                <a:solidFill>
+                  <a:srgbClr val="9FB8C0"/>
+                </a:solidFill>
+                <a:latin typeface="Calibri" pitchFamily="34" charset="0"/>
+                <a:ea typeface="Calibri" pitchFamily="34" charset="-122"/>
+                <a:cs typeface="Calibri" pitchFamily="34" charset="-120"/>
+              </a:rPr>
+              <a:t>Prachit</a:t>
+            </a:r>
+            <a:r>
+              <a:rPr lang="en-US" sz="1300" dirty="0">
+                <a:solidFill>
+                  <a:srgbClr val="9FB8C0"/>
+                </a:solidFill>
+                <a:latin typeface="Calibri" pitchFamily="34" charset="0"/>
+                <a:ea typeface="Calibri" pitchFamily="34" charset="-122"/>
+                <a:cs typeface="Calibri" pitchFamily="34" charset="-120"/>
+              </a:rPr>
+              <a:t> </a:t>
+            </a:r>
+            <a:r>
+              <a:rPr lang="en-US" sz="1300" dirty="0" err="1">
+                <a:solidFill>
+                  <a:srgbClr val="9FB8C0"/>
+                </a:solidFill>
+                <a:latin typeface="Calibri" pitchFamily="34" charset="0"/>
+                <a:ea typeface="Calibri" pitchFamily="34" charset="-122"/>
+                <a:cs typeface="Calibri" pitchFamily="34" charset="-120"/>
+              </a:rPr>
+              <a:t>Deshinge</a:t>
+            </a:r>
+            <a:r>
+              <a:rPr lang="en-US" sz="1300" dirty="0">
+                <a:solidFill>
+                  <a:srgbClr val="9FB8C0"/>
+                </a:solidFill>
+                <a:latin typeface="Calibri" pitchFamily="34" charset="0"/>
+                <a:ea typeface="Calibri" pitchFamily="34" charset="-122"/>
+                <a:cs typeface="Calibri" pitchFamily="34" charset="-120"/>
+              </a:rPr>
+              <a:t> and Namish Kumar</a:t>
             </a:r>
             <a:endParaRPr lang="en-US" sz="1300" dirty="0"/>
           </a:p>
@@ -1678,9 +1505,9 @@
           <p:nvPr/>
         </p:nvSpPr>
         <p:spPr>
-          <a:xfrm>
-            <a:off x="7909560" y="1508760"/>
-            <a:ext cx="-731520" cy="1645920"/>
+          <a:xfrm flipH="1">
+            <a:off x="7315200" y="1508760"/>
+            <a:ext cx="594360" cy="1234440"/>
           </a:xfrm>
           <a:prstGeom prst="line">
             <a:avLst/>
@@ -1786,7 +1613,7 @@
           <a:bodyPr wrap="square" lIns="0" tIns="0" rIns="0" bIns="0" rtlCol="0" anchor="t"/>
           <a:lstStyle/>
           <a:p>
-            <a:pPr algn="ctr" indent="0" marL="0">
+            <a:pPr marL="0" indent="0" algn="ctr">
               <a:buNone/>
             </a:pPr>
             <a:r>
@@ -1850,7 +1677,7 @@
           <a:bodyPr wrap="square" lIns="0" tIns="0" rIns="0" bIns="0" rtlCol="0" anchor="t"/>
           <a:lstStyle/>
           <a:p>
-            <a:pPr algn="ctr" indent="0" marL="0">
+            <a:pPr marL="0" indent="0" algn="ctr">
               <a:buNone/>
             </a:pPr>
             <a:r>
@@ -1914,7 +1741,7 @@
           <a:bodyPr wrap="square" lIns="0" tIns="0" rIns="0" bIns="0" rtlCol="0" anchor="t"/>
           <a:lstStyle/>
           <a:p>
-            <a:pPr algn="ctr" indent="0" marL="0">
+            <a:pPr marL="0" indent="0" algn="ctr">
               <a:buNone/>
             </a:pPr>
             <a:r>
@@ -1948,6 +1775,7 @@
         <a:solidFill>
           <a:srgbClr val="EAF5F3"/>
         </a:solidFill>
+        <a:effectLst/>
       </p:bgPr>
     </p:bg>
     <p:spTree>
@@ -1985,7 +1813,7 @@
           <a:bodyPr wrap="square" lIns="0" tIns="0" rIns="0" bIns="0" rtlCol="0" anchor="ctr"/>
           <a:lstStyle/>
           <a:p>
-            <a:pPr indent="0" marL="0">
+            <a:pPr marL="0" indent="0">
               <a:buNone/>
             </a:pPr>
             <a:r>
@@ -2029,7 +1857,7 @@
             <a:prstDash val="solid"/>
           </a:ln>
           <a:effectLst>
-            <a:outerShdw sx="100000" sy="100000" kx="0" ky="0" algn="bl" rotWithShape="0" blurRad="76200" dist="25400" dir="5400000">
+            <a:outerShdw blurRad="76200" dist="25400" dir="5400000" algn="bl" rotWithShape="0">
               <a:srgbClr val="000000">
                 <a:alpha val="12000"/>
               </a:srgbClr>
@@ -2083,7 +1911,7 @@
           <a:bodyPr wrap="square" lIns="0" tIns="0" rIns="0" bIns="0" rtlCol="0" anchor="ctr"/>
           <a:lstStyle/>
           <a:p>
-            <a:pPr algn="ctr" indent="0" marL="0">
+            <a:pPr marL="0" indent="0" algn="ctr">
               <a:buNone/>
             </a:pPr>
             <a:r>
@@ -2122,7 +1950,7 @@
           <a:bodyPr wrap="square" lIns="0" tIns="0" rIns="0" bIns="0" rtlCol="0" anchor="ctr"/>
           <a:lstStyle/>
           <a:p>
-            <a:pPr indent="0" marL="0">
+            <a:pPr marL="0" indent="0">
               <a:buNone/>
             </a:pPr>
             <a:r>
@@ -2161,7 +1989,7 @@
           <a:bodyPr wrap="square" lIns="0" tIns="0" rIns="0" bIns="0" rtlCol="0" anchor="ctr"/>
           <a:lstStyle/>
           <a:p>
-            <a:pPr indent="0" marL="0">
+            <a:pPr marL="0" indent="0">
               <a:buNone/>
             </a:pPr>
             <a:r>
@@ -2205,7 +2033,7 @@
             <a:prstDash val="solid"/>
           </a:ln>
           <a:effectLst>
-            <a:outerShdw sx="100000" sy="100000" kx="0" ky="0" algn="bl" rotWithShape="0" blurRad="76200" dist="25400" dir="5400000">
+            <a:outerShdw blurRad="76200" dist="25400" dir="5400000" algn="bl" rotWithShape="0">
               <a:srgbClr val="000000">
                 <a:alpha val="12000"/>
               </a:srgbClr>
@@ -2259,7 +2087,7 @@
           <a:bodyPr wrap="square" lIns="0" tIns="0" rIns="0" bIns="0" rtlCol="0" anchor="ctr"/>
           <a:lstStyle/>
           <a:p>
-            <a:pPr algn="ctr" indent="0" marL="0">
+            <a:pPr marL="0" indent="0" algn="ctr">
               <a:buNone/>
             </a:pPr>
             <a:r>
@@ -2298,7 +2126,7 @@
           <a:bodyPr wrap="square" lIns="0" tIns="0" rIns="0" bIns="0" rtlCol="0" anchor="ctr"/>
           <a:lstStyle/>
           <a:p>
-            <a:pPr indent="0" marL="0">
+            <a:pPr marL="0" indent="0">
               <a:buNone/>
             </a:pPr>
             <a:r>
@@ -2337,7 +2165,7 @@
           <a:bodyPr wrap="square" lIns="0" tIns="0" rIns="0" bIns="0" rtlCol="0" anchor="ctr"/>
           <a:lstStyle/>
           <a:p>
-            <a:pPr indent="0" marL="0">
+            <a:pPr marL="0" indent="0">
               <a:buNone/>
             </a:pPr>
             <a:r>
@@ -2381,7 +2209,7 @@
             <a:prstDash val="solid"/>
           </a:ln>
           <a:effectLst>
-            <a:outerShdw sx="100000" sy="100000" kx="0" ky="0" algn="bl" rotWithShape="0" blurRad="76200" dist="25400" dir="5400000">
+            <a:outerShdw blurRad="76200" dist="25400" dir="5400000" algn="bl" rotWithShape="0">
               <a:srgbClr val="000000">
                 <a:alpha val="12000"/>
               </a:srgbClr>
@@ -2435,7 +2263,7 @@
           <a:bodyPr wrap="square" lIns="0" tIns="0" rIns="0" bIns="0" rtlCol="0" anchor="ctr"/>
           <a:lstStyle/>
           <a:p>
-            <a:pPr algn="ctr" indent="0" marL="0">
+            <a:pPr marL="0" indent="0" algn="ctr">
               <a:buNone/>
             </a:pPr>
             <a:r>
@@ -2474,7 +2302,7 @@
           <a:bodyPr wrap="square" lIns="0" tIns="0" rIns="0" bIns="0" rtlCol="0" anchor="ctr"/>
           <a:lstStyle/>
           <a:p>
-            <a:pPr indent="0" marL="0">
+            <a:pPr marL="0" indent="0">
               <a:buNone/>
             </a:pPr>
             <a:r>
@@ -2513,7 +2341,7 @@
           <a:bodyPr wrap="square" lIns="0" tIns="0" rIns="0" bIns="0" rtlCol="0" anchor="ctr"/>
           <a:lstStyle/>
           <a:p>
-            <a:pPr indent="0" marL="0">
+            <a:pPr marL="0" indent="0">
               <a:buNone/>
             </a:pPr>
             <a:r>
@@ -2557,7 +2385,7 @@
             <a:prstDash val="solid"/>
           </a:ln>
           <a:effectLst>
-            <a:outerShdw sx="100000" sy="100000" kx="0" ky="0" algn="bl" rotWithShape="0" blurRad="76200" dist="25400" dir="5400000">
+            <a:outerShdw blurRad="76200" dist="25400" dir="5400000" algn="bl" rotWithShape="0">
               <a:srgbClr val="000000">
                 <a:alpha val="12000"/>
               </a:srgbClr>
@@ -2611,7 +2439,7 @@
           <a:bodyPr wrap="square" lIns="0" tIns="0" rIns="0" bIns="0" rtlCol="0" anchor="ctr"/>
           <a:lstStyle/>
           <a:p>
-            <a:pPr algn="ctr" indent="0" marL="0">
+            <a:pPr marL="0" indent="0" algn="ctr">
               <a:buNone/>
             </a:pPr>
             <a:r>
@@ -2650,7 +2478,7 @@
           <a:bodyPr wrap="square" lIns="0" tIns="0" rIns="0" bIns="0" rtlCol="0" anchor="ctr"/>
           <a:lstStyle/>
           <a:p>
-            <a:pPr indent="0" marL="0">
+            <a:pPr marL="0" indent="0">
               <a:buNone/>
             </a:pPr>
             <a:r>
@@ -2689,7 +2517,7 @@
           <a:bodyPr wrap="square" lIns="0" tIns="0" rIns="0" bIns="0" rtlCol="0" anchor="ctr"/>
           <a:lstStyle/>
           <a:p>
-            <a:pPr indent="0" marL="0">
+            <a:pPr marL="0" indent="0">
               <a:buNone/>
             </a:pPr>
             <a:r>
@@ -2733,7 +2561,7 @@
             <a:prstDash val="solid"/>
           </a:ln>
           <a:effectLst>
-            <a:outerShdw sx="100000" sy="100000" kx="0" ky="0" algn="bl" rotWithShape="0" blurRad="76200" dist="25400" dir="5400000">
+            <a:outerShdw blurRad="76200" dist="25400" dir="5400000" algn="bl" rotWithShape="0">
               <a:srgbClr val="000000">
                 <a:alpha val="12000"/>
               </a:srgbClr>
@@ -2787,7 +2615,7 @@
           <a:bodyPr wrap="square" lIns="0" tIns="0" rIns="0" bIns="0" rtlCol="0" anchor="ctr"/>
           <a:lstStyle/>
           <a:p>
-            <a:pPr algn="ctr" indent="0" marL="0">
+            <a:pPr marL="0" indent="0" algn="ctr">
               <a:buNone/>
             </a:pPr>
             <a:r>
@@ -2826,7 +2654,7 @@
           <a:bodyPr wrap="square" lIns="0" tIns="0" rIns="0" bIns="0" rtlCol="0" anchor="ctr"/>
           <a:lstStyle/>
           <a:p>
-            <a:pPr indent="0" marL="0">
+            <a:pPr marL="0" indent="0">
               <a:buNone/>
             </a:pPr>
             <a:r>
@@ -2865,7 +2693,7 @@
           <a:bodyPr wrap="square" lIns="0" tIns="0" rIns="0" bIns="0" rtlCol="0" anchor="ctr"/>
           <a:lstStyle/>
           <a:p>
-            <a:pPr indent="0" marL="0">
+            <a:pPr marL="0" indent="0">
               <a:buNone/>
             </a:pPr>
             <a:r>
@@ -2899,6 +2727,7 @@
         <a:solidFill>
           <a:srgbClr val="EAF5F3"/>
         </a:solidFill>
+        <a:effectLst/>
       </p:bgPr>
     </p:bg>
     <p:spTree>
@@ -2936,7 +2765,7 @@
           <a:bodyPr wrap="square" lIns="0" tIns="0" rIns="0" bIns="0" rtlCol="0" anchor="ctr"/>
           <a:lstStyle/>
           <a:p>
-            <a:pPr indent="0" marL="0">
+            <a:pPr marL="0" indent="0">
               <a:buNone/>
             </a:pPr>
             <a:r>
@@ -2980,7 +2809,7 @@
             <a:prstDash val="solid"/>
           </a:ln>
           <a:effectLst>
-            <a:outerShdw sx="100000" sy="100000" kx="0" ky="0" algn="bl" rotWithShape="0" blurRad="76200" dist="25400" dir="5400000">
+            <a:outerShdw blurRad="76200" dist="25400" dir="5400000" algn="bl" rotWithShape="0">
               <a:srgbClr val="000000">
                 <a:alpha val="12000"/>
               </a:srgbClr>
@@ -3009,7 +2838,7 @@
           <a:bodyPr wrap="square" lIns="0" tIns="0" rIns="0" bIns="0" rtlCol="0" anchor="t"/>
           <a:lstStyle/>
           <a:p>
-            <a:pPr indent="0" marL="0">
+            <a:pPr marL="0" indent="0">
               <a:buNone/>
             </a:pPr>
             <a:r>
@@ -3048,7 +2877,7 @@
           <a:bodyPr wrap="square" lIns="0" tIns="0" rIns="0" bIns="0" rtlCol="0" anchor="t"/>
           <a:lstStyle/>
           <a:p>
-            <a:pPr indent="0" marL="0">
+            <a:pPr marL="0" indent="0">
               <a:buNone/>
             </a:pPr>
             <a:r>
@@ -3087,7 +2916,7 @@
           <a:bodyPr wrap="square" lIns="0" tIns="0" rIns="0" bIns="0" rtlCol="0" anchor="t"/>
           <a:lstStyle/>
           <a:p>
-            <a:pPr indent="0" marL="0">
+            <a:pPr marL="0" indent="0">
               <a:buNone/>
             </a:pPr>
             <a:r>
@@ -3153,7 +2982,7 @@
           <a:bodyPr wrap="square" lIns="0" tIns="0" rIns="0" bIns="0" rtlCol="0" anchor="t"/>
           <a:lstStyle/>
           <a:p>
-            <a:pPr indent="0" marL="0">
+            <a:pPr marL="0" indent="0">
               <a:buNone/>
             </a:pPr>
             <a:r>
@@ -3192,7 +3021,7 @@
           <a:bodyPr wrap="square" lIns="0" tIns="0" rIns="0" bIns="0" rtlCol="0" anchor="t"/>
           <a:lstStyle/>
           <a:p>
-            <a:pPr indent="0" marL="0">
+            <a:pPr marL="0" indent="0">
               <a:buNone/>
             </a:pPr>
             <a:r>
@@ -3258,7 +3087,7 @@
           <a:bodyPr wrap="square" lIns="0" tIns="0" rIns="0" bIns="0" rtlCol="0" anchor="ctr"/>
           <a:lstStyle/>
           <a:p>
-            <a:pPr indent="0" marL="0">
+            <a:pPr marL="0" indent="0">
               <a:buNone/>
             </a:pPr>
             <a:r>
@@ -3324,7 +3153,7 @@
           <a:bodyPr wrap="square" lIns="0" tIns="0" rIns="0" bIns="0" rtlCol="0" anchor="ctr"/>
           <a:lstStyle/>
           <a:p>
-            <a:pPr indent="0" marL="0">
+            <a:pPr marL="0" indent="0">
               <a:buNone/>
             </a:pPr>
             <a:r>
@@ -3390,7 +3219,7 @@
           <a:bodyPr wrap="square" lIns="0" tIns="0" rIns="0" bIns="0" rtlCol="0" anchor="ctr"/>
           <a:lstStyle/>
           <a:p>
-            <a:pPr indent="0" marL="0">
+            <a:pPr marL="0" indent="0">
               <a:buNone/>
             </a:pPr>
             <a:r>
@@ -3456,7 +3285,7 @@
           <a:bodyPr wrap="square" lIns="0" tIns="0" rIns="0" bIns="0" rtlCol="0" anchor="ctr"/>
           <a:lstStyle/>
           <a:p>
-            <a:pPr indent="0" marL="0">
+            <a:pPr marL="0" indent="0">
               <a:buNone/>
             </a:pPr>
             <a:r>
@@ -3522,7 +3351,7 @@
           <a:bodyPr wrap="square" lIns="0" tIns="0" rIns="0" bIns="0" rtlCol="0" anchor="ctr"/>
           <a:lstStyle/>
           <a:p>
-            <a:pPr indent="0" marL="0">
+            <a:pPr marL="0" indent="0">
               <a:buNone/>
             </a:pPr>
             <a:r>
@@ -3566,7 +3395,7 @@
             <a:prstDash val="solid"/>
           </a:ln>
           <a:effectLst>
-            <a:outerShdw sx="100000" sy="100000" kx="0" ky="0" algn="bl" rotWithShape="0" blurRad="76200" dist="25400" dir="5400000">
+            <a:outerShdw blurRad="76200" dist="25400" dir="5400000" algn="bl" rotWithShape="0">
               <a:srgbClr val="000000">
                 <a:alpha val="12000"/>
               </a:srgbClr>
@@ -3595,7 +3424,7 @@
           <a:bodyPr wrap="square" lIns="0" tIns="0" rIns="0" bIns="0" rtlCol="0" anchor="t"/>
           <a:lstStyle/>
           <a:p>
-            <a:pPr indent="0" marL="0">
+            <a:pPr marL="0" indent="0">
               <a:buNone/>
             </a:pPr>
             <a:r>
@@ -3634,7 +3463,7 @@
           <a:bodyPr wrap="square" lIns="0" tIns="0" rIns="0" bIns="0" rtlCol="0" anchor="t"/>
           <a:lstStyle/>
           <a:p>
-            <a:pPr indent="0" marL="0">
+            <a:pPr marL="0" indent="0">
               <a:buNone/>
             </a:pPr>
             <a:r>
@@ -3673,7 +3502,7 @@
           <a:bodyPr wrap="square" lIns="0" tIns="0" rIns="0" bIns="0" rtlCol="0" anchor="t"/>
           <a:lstStyle/>
           <a:p>
-            <a:pPr indent="0" marL="0">
+            <a:pPr marL="0" indent="0">
               <a:buNone/>
             </a:pPr>
             <a:r>
@@ -3690,13 +3519,13 @@
             <a:endParaRPr lang="en-US" sz="1100" dirty="0"/>
           </a:p>
           <a:p>
-            <a:pPr indent="0" marL="0">
+            <a:pPr marL="0" indent="0">
               <a:buNone/>
             </a:pPr>
             <a:endParaRPr lang="en-US" sz="1100" dirty="0"/>
           </a:p>
           <a:p>
-            <a:pPr indent="0" marL="0">
+            <a:pPr marL="0" indent="0">
               <a:buNone/>
             </a:pPr>
             <a:r>
@@ -3713,7 +3542,7 @@
             <a:endParaRPr lang="en-US" sz="1100" dirty="0"/>
           </a:p>
           <a:p>
-            <a:pPr indent="0" marL="0">
+            <a:pPr marL="0" indent="0">
               <a:buNone/>
             </a:pPr>
             <a:r>
@@ -3777,7 +3606,7 @@
           <a:bodyPr wrap="square" lIns="0" tIns="0" rIns="0" bIns="0" rtlCol="0" anchor="t"/>
           <a:lstStyle/>
           <a:p>
-            <a:pPr algn="ctr" indent="0" marL="0">
+            <a:pPr marL="0" indent="0" algn="ctr">
               <a:buNone/>
             </a:pPr>
             <a:r>
@@ -3794,7 +3623,7 @@
             <a:endParaRPr lang="en-US" sz="1000" dirty="0"/>
           </a:p>
           <a:p>
-            <a:pPr algn="ctr" indent="0" marL="0">
+            <a:pPr marL="0" indent="0" algn="ctr">
               <a:buNone/>
             </a:pPr>
             <a:r>
@@ -3858,7 +3687,7 @@
           <a:bodyPr wrap="square" lIns="0" tIns="0" rIns="0" bIns="0" rtlCol="0" anchor="t"/>
           <a:lstStyle/>
           <a:p>
-            <a:pPr algn="ctr" indent="0" marL="0">
+            <a:pPr marL="0" indent="0" algn="ctr">
               <a:buNone/>
             </a:pPr>
             <a:r>
@@ -3897,7 +3726,7 @@
           <a:bodyPr wrap="square" lIns="0" tIns="0" rIns="0" bIns="0" rtlCol="0" anchor="t"/>
           <a:lstStyle/>
           <a:p>
-            <a:pPr indent="0" marL="0">
+            <a:pPr marL="0" indent="0">
               <a:buNone/>
             </a:pPr>
             <a:r>
@@ -3931,6 +3760,7 @@
         <a:solidFill>
           <a:srgbClr val="EAF5F3"/>
         </a:solidFill>
+        <a:effectLst/>
       </p:bgPr>
     </p:bg>
     <p:spTree>
@@ -3968,7 +3798,7 @@
           <a:bodyPr wrap="square" lIns="0" tIns="0" rIns="0" bIns="0" rtlCol="0" anchor="ctr"/>
           <a:lstStyle/>
           <a:p>
-            <a:pPr indent="0" marL="0">
+            <a:pPr marL="0" indent="0">
               <a:buNone/>
             </a:pPr>
             <a:r>
@@ -4002,16 +3832,34 @@
         </p:nvGraphicFramePr>
         <p:xfrm>
           <a:off x="457200" y="1188720"/>
-          <a:ext cx="5120640" cy="914400"/>
+          <a:ext cx="5120640" cy="2304288"/>
         </p:xfrm>
         <a:graphic>
           <a:graphicData uri="http://schemas.openxmlformats.org/drawingml/2006/table">
             <a:tbl>
               <a:tblPr/>
               <a:tblGrid>
-                <a:gridCol w="868680"/>
-                <a:gridCol w="1600200"/>
-                <a:gridCol w="2651760"/>
+                <a:gridCol w="868680">
+                  <a:extLst>
+                    <a:ext uri="{9D8B030D-6E8A-4147-A177-3AD203B41FA5}">
+                      <a16:colId xmlns:a16="http://schemas.microsoft.com/office/drawing/2014/main" val="20000"/>
+                    </a:ext>
+                  </a:extLst>
+                </a:gridCol>
+                <a:gridCol w="1600200">
+                  <a:extLst>
+                    <a:ext uri="{9D8B030D-6E8A-4147-A177-3AD203B41FA5}">
+                      <a16:colId xmlns:a16="http://schemas.microsoft.com/office/drawing/2014/main" val="20001"/>
+                    </a:ext>
+                  </a:extLst>
+                </a:gridCol>
+                <a:gridCol w="2651760">
+                  <a:extLst>
+                    <a:ext uri="{9D8B030D-6E8A-4147-A177-3AD203B41FA5}">
+                      <a16:colId xmlns:a16="http://schemas.microsoft.com/office/drawing/2014/main" val="20002"/>
+                    </a:ext>
+                  </a:extLst>
+                </a:gridCol>
               </a:tblGrid>
               <a:tr h="329184">
                 <a:tc>
@@ -4019,7 +3867,7 @@
                     <a:bodyPr/>
                     <a:lstStyle/>
                     <a:p>
-                      <a:pPr indent="0" marL="0">
+                      <a:pPr marL="0" indent="0">
                         <a:buNone/>
                       </a:pPr>
                       <a:r>
@@ -4040,7 +3888,7 @@
                       </a:endParaRPr>
                     </a:p>
                   </a:txBody>
-                  <a:tcPr marL="91440" marR="91440" marT="45720" marB="45720" anchor="ctr">
+                  <a:tcPr anchor="ctr">
                     <a:lnL w="9525" cap="flat" cmpd="sng" algn="ctr">
                       <a:solidFill>
                         <a:srgbClr val="D5E3E0"/>
@@ -4087,7 +3935,7 @@
                     <a:bodyPr/>
                     <a:lstStyle/>
                     <a:p>
-                      <a:pPr indent="0" marL="0">
+                      <a:pPr marL="0" indent="0">
                         <a:buNone/>
                       </a:pPr>
                       <a:r>
@@ -4108,7 +3956,7 @@
                       </a:endParaRPr>
                     </a:p>
                   </a:txBody>
-                  <a:tcPr marL="91440" marR="91440" marT="45720" marB="45720" anchor="ctr">
+                  <a:tcPr anchor="ctr">
                     <a:lnL w="9525" cap="flat" cmpd="sng" algn="ctr">
                       <a:solidFill>
                         <a:srgbClr val="D5E3E0"/>
@@ -4155,7 +4003,7 @@
                     <a:bodyPr/>
                     <a:lstStyle/>
                     <a:p>
-                      <a:pPr indent="0" marL="0">
+                      <a:pPr marL="0" indent="0">
                         <a:buNone/>
                       </a:pPr>
                       <a:r>
@@ -4176,7 +4024,7 @@
                       </a:endParaRPr>
                     </a:p>
                   </a:txBody>
-                  <a:tcPr marL="91440" marR="91440" marT="45720" marB="45720" anchor="ctr">
+                  <a:tcPr anchor="ctr">
                     <a:lnL w="9525" cap="flat" cmpd="sng" algn="ctr">
                       <a:solidFill>
                         <a:srgbClr val="D5E3E0"/>
@@ -4218,6 +4066,11 @@
                     </a:solidFill>
                   </a:tcPr>
                 </a:tc>
+                <a:extLst>
+                  <a:ext uri="{0D108BD9-81ED-4DB2-BD59-A6C34878D82A}">
+                    <a16:rowId xmlns:a16="http://schemas.microsoft.com/office/drawing/2014/main" val="10000"/>
+                  </a:ext>
+                </a:extLst>
               </a:tr>
               <a:tr h="329184">
                 <a:tc>
@@ -4225,7 +4078,7 @@
                     <a:bodyPr/>
                     <a:lstStyle/>
                     <a:p>
-                      <a:pPr indent="0" marL="0">
+                      <a:pPr marL="0" indent="0">
                         <a:buNone/>
                       </a:pPr>
                       <a:r>
@@ -4246,7 +4099,7 @@
                       </a:endParaRPr>
                     </a:p>
                   </a:txBody>
-                  <a:tcPr marL="91440" marR="91440" marT="45720" marB="45720" anchor="ctr">
+                  <a:tcPr anchor="ctr">
                     <a:lnL w="9525" cap="flat" cmpd="sng" algn="ctr">
                       <a:solidFill>
                         <a:srgbClr val="D5E3E0"/>
@@ -4293,7 +4146,7 @@
                     <a:bodyPr/>
                     <a:lstStyle/>
                     <a:p>
-                      <a:pPr indent="0" marL="0">
+                      <a:pPr marL="0" indent="0">
                         <a:buNone/>
                       </a:pPr>
                       <a:r>
@@ -4314,7 +4167,7 @@
                       </a:endParaRPr>
                     </a:p>
                   </a:txBody>
-                  <a:tcPr marL="91440" marR="91440" marT="45720" marB="45720" anchor="ctr">
+                  <a:tcPr anchor="ctr">
                     <a:lnL w="9525" cap="flat" cmpd="sng" algn="ctr">
                       <a:solidFill>
                         <a:srgbClr val="D5E3E0"/>
@@ -4361,7 +4214,7 @@
                     <a:bodyPr/>
                     <a:lstStyle/>
                     <a:p>
-                      <a:pPr indent="0" marL="0">
+                      <a:pPr marL="0" indent="0">
                         <a:buNone/>
                       </a:pPr>
                       <a:r>
@@ -4382,7 +4235,7 @@
                       </a:endParaRPr>
                     </a:p>
                   </a:txBody>
-                  <a:tcPr marL="91440" marR="91440" marT="45720" marB="45720" anchor="ctr">
+                  <a:tcPr anchor="ctr">
                     <a:lnL w="9525" cap="flat" cmpd="sng" algn="ctr">
                       <a:solidFill>
                         <a:srgbClr val="D5E3E0"/>
@@ -4424,6 +4277,11 @@
                     </a:solidFill>
                   </a:tcPr>
                 </a:tc>
+                <a:extLst>
+                  <a:ext uri="{0D108BD9-81ED-4DB2-BD59-A6C34878D82A}">
+                    <a16:rowId xmlns:a16="http://schemas.microsoft.com/office/drawing/2014/main" val="10001"/>
+                  </a:ext>
+                </a:extLst>
               </a:tr>
               <a:tr h="329184">
                 <a:tc>
@@ -4431,7 +4289,7 @@
                     <a:bodyPr/>
                     <a:lstStyle/>
                     <a:p>
-                      <a:pPr indent="0" marL="0">
+                      <a:pPr marL="0" indent="0">
                         <a:buNone/>
                       </a:pPr>
                       <a:r>
@@ -4452,7 +4310,7 @@
                       </a:endParaRPr>
                     </a:p>
                   </a:txBody>
-                  <a:tcPr marL="91440" marR="91440" marT="45720" marB="45720" anchor="ctr">
+                  <a:tcPr anchor="ctr">
                     <a:lnL w="9525" cap="flat" cmpd="sng" algn="ctr">
                       <a:solidFill>
                         <a:srgbClr val="D5E3E0"/>
@@ -4499,7 +4357,7 @@
                     <a:bodyPr/>
                     <a:lstStyle/>
                     <a:p>
-                      <a:pPr indent="0" marL="0">
+                      <a:pPr marL="0" indent="0">
                         <a:buNone/>
                       </a:pPr>
                       <a:r>
@@ -4520,7 +4378,7 @@
                       </a:endParaRPr>
                     </a:p>
                   </a:txBody>
-                  <a:tcPr marL="91440" marR="91440" marT="45720" marB="45720" anchor="ctr">
+                  <a:tcPr anchor="ctr">
                     <a:lnL w="9525" cap="flat" cmpd="sng" algn="ctr">
                       <a:solidFill>
                         <a:srgbClr val="D5E3E0"/>
@@ -4567,7 +4425,7 @@
                     <a:bodyPr/>
                     <a:lstStyle/>
                     <a:p>
-                      <a:pPr indent="0" marL="0">
+                      <a:pPr marL="0" indent="0">
                         <a:buNone/>
                       </a:pPr>
                       <a:r>
@@ -4588,7 +4446,7 @@
                       </a:endParaRPr>
                     </a:p>
                   </a:txBody>
-                  <a:tcPr marL="91440" marR="91440" marT="45720" marB="45720" anchor="ctr">
+                  <a:tcPr anchor="ctr">
                     <a:lnL w="9525" cap="flat" cmpd="sng" algn="ctr">
                       <a:solidFill>
                         <a:srgbClr val="D5E3E0"/>
@@ -4630,6 +4488,11 @@
                     </a:solidFill>
                   </a:tcPr>
                 </a:tc>
+                <a:extLst>
+                  <a:ext uri="{0D108BD9-81ED-4DB2-BD59-A6C34878D82A}">
+                    <a16:rowId xmlns:a16="http://schemas.microsoft.com/office/drawing/2014/main" val="10002"/>
+                  </a:ext>
+                </a:extLst>
               </a:tr>
               <a:tr h="329184">
                 <a:tc>
@@ -4637,7 +4500,7 @@
                     <a:bodyPr/>
                     <a:lstStyle/>
                     <a:p>
-                      <a:pPr indent="0" marL="0">
+                      <a:pPr marL="0" indent="0">
                         <a:buNone/>
                       </a:pPr>
                       <a:r>
@@ -4658,7 +4521,7 @@
                       </a:endParaRPr>
                     </a:p>
                   </a:txBody>
-                  <a:tcPr marL="91440" marR="91440" marT="45720" marB="45720" anchor="ctr">
+                  <a:tcPr anchor="ctr">
                     <a:lnL w="9525" cap="flat" cmpd="sng" algn="ctr">
                       <a:solidFill>
                         <a:srgbClr val="D5E3E0"/>
@@ -4705,7 +4568,7 @@
                     <a:bodyPr/>
                     <a:lstStyle/>
                     <a:p>
-                      <a:pPr indent="0" marL="0">
+                      <a:pPr marL="0" indent="0">
                         <a:buNone/>
                       </a:pPr>
                       <a:r>
@@ -4726,7 +4589,7 @@
                       </a:endParaRPr>
                     </a:p>
                   </a:txBody>
-                  <a:tcPr marL="91440" marR="91440" marT="45720" marB="45720" anchor="ctr">
+                  <a:tcPr anchor="ctr">
                     <a:lnL w="9525" cap="flat" cmpd="sng" algn="ctr">
                       <a:solidFill>
                         <a:srgbClr val="D5E3E0"/>
@@ -4773,7 +4636,7 @@
                     <a:bodyPr/>
                     <a:lstStyle/>
                     <a:p>
-                      <a:pPr indent="0" marL="0">
+                      <a:pPr marL="0" indent="0">
                         <a:buNone/>
                       </a:pPr>
                       <a:r>
@@ -4794,7 +4657,7 @@
                       </a:endParaRPr>
                     </a:p>
                   </a:txBody>
-                  <a:tcPr marL="91440" marR="91440" marT="45720" marB="45720" anchor="ctr">
+                  <a:tcPr anchor="ctr">
                     <a:lnL w="9525" cap="flat" cmpd="sng" algn="ctr">
                       <a:solidFill>
                         <a:srgbClr val="D5E3E0"/>
@@ -4836,6 +4699,11 @@
                     </a:solidFill>
                   </a:tcPr>
                 </a:tc>
+                <a:extLst>
+                  <a:ext uri="{0D108BD9-81ED-4DB2-BD59-A6C34878D82A}">
+                    <a16:rowId xmlns:a16="http://schemas.microsoft.com/office/drawing/2014/main" val="10003"/>
+                  </a:ext>
+                </a:extLst>
               </a:tr>
               <a:tr h="329184">
                 <a:tc>
@@ -4843,7 +4711,7 @@
                     <a:bodyPr/>
                     <a:lstStyle/>
                     <a:p>
-                      <a:pPr indent="0" marL="0">
+                      <a:pPr marL="0" indent="0">
                         <a:buNone/>
                       </a:pPr>
                       <a:r>
@@ -4864,7 +4732,7 @@
                       </a:endParaRPr>
                     </a:p>
                   </a:txBody>
-                  <a:tcPr marL="91440" marR="91440" marT="45720" marB="45720" anchor="ctr">
+                  <a:tcPr anchor="ctr">
                     <a:lnL w="9525" cap="flat" cmpd="sng" algn="ctr">
                       <a:solidFill>
                         <a:srgbClr val="D5E3E0"/>
@@ -4911,7 +4779,7 @@
                     <a:bodyPr/>
                     <a:lstStyle/>
                     <a:p>
-                      <a:pPr indent="0" marL="0">
+                      <a:pPr marL="0" indent="0">
                         <a:buNone/>
                       </a:pPr>
                       <a:r>
@@ -4932,7 +4800,7 @@
                       </a:endParaRPr>
                     </a:p>
                   </a:txBody>
-                  <a:tcPr marL="91440" marR="91440" marT="45720" marB="45720" anchor="ctr">
+                  <a:tcPr anchor="ctr">
                     <a:lnL w="9525" cap="flat" cmpd="sng" algn="ctr">
                       <a:solidFill>
                         <a:srgbClr val="D5E3E0"/>
@@ -4979,7 +4847,7 @@
                     <a:bodyPr/>
                     <a:lstStyle/>
                     <a:p>
-                      <a:pPr indent="0" marL="0">
+                      <a:pPr marL="0" indent="0">
                         <a:buNone/>
                       </a:pPr>
                       <a:r>
@@ -5000,7 +4868,7 @@
                       </a:endParaRPr>
                     </a:p>
                   </a:txBody>
-                  <a:tcPr marL="91440" marR="91440" marT="45720" marB="45720" anchor="ctr">
+                  <a:tcPr anchor="ctr">
                     <a:lnL w="9525" cap="flat" cmpd="sng" algn="ctr">
                       <a:solidFill>
                         <a:srgbClr val="D5E3E0"/>
@@ -5042,6 +4910,11 @@
                     </a:solidFill>
                   </a:tcPr>
                 </a:tc>
+                <a:extLst>
+                  <a:ext uri="{0D108BD9-81ED-4DB2-BD59-A6C34878D82A}">
+                    <a16:rowId xmlns:a16="http://schemas.microsoft.com/office/drawing/2014/main" val="10004"/>
+                  </a:ext>
+                </a:extLst>
               </a:tr>
               <a:tr h="329184">
                 <a:tc>
@@ -5049,7 +4922,7 @@
                     <a:bodyPr/>
                     <a:lstStyle/>
                     <a:p>
-                      <a:pPr indent="0" marL="0">
+                      <a:pPr marL="0" indent="0">
                         <a:buNone/>
                       </a:pPr>
                       <a:r>
@@ -5070,7 +4943,7 @@
                       </a:endParaRPr>
                     </a:p>
                   </a:txBody>
-                  <a:tcPr marL="91440" marR="91440" marT="45720" marB="45720" anchor="ctr">
+                  <a:tcPr anchor="ctr">
                     <a:lnL w="9525" cap="flat" cmpd="sng" algn="ctr">
                       <a:solidFill>
                         <a:srgbClr val="D5E3E0"/>
@@ -5117,7 +4990,7 @@
                     <a:bodyPr/>
                     <a:lstStyle/>
                     <a:p>
-                      <a:pPr indent="0" marL="0">
+                      <a:pPr marL="0" indent="0">
                         <a:buNone/>
                       </a:pPr>
                       <a:r>
@@ -5138,7 +5011,7 @@
                       </a:endParaRPr>
                     </a:p>
                   </a:txBody>
-                  <a:tcPr marL="91440" marR="91440" marT="45720" marB="45720" anchor="ctr">
+                  <a:tcPr anchor="ctr">
                     <a:lnL w="9525" cap="flat" cmpd="sng" algn="ctr">
                       <a:solidFill>
                         <a:srgbClr val="D5E3E0"/>
@@ -5185,7 +5058,7 @@
                     <a:bodyPr/>
                     <a:lstStyle/>
                     <a:p>
-                      <a:pPr indent="0" marL="0">
+                      <a:pPr marL="0" indent="0">
                         <a:buNone/>
                       </a:pPr>
                       <a:r>
@@ -5206,7 +5079,7 @@
                       </a:endParaRPr>
                     </a:p>
                   </a:txBody>
-                  <a:tcPr marL="91440" marR="91440" marT="45720" marB="45720" anchor="ctr">
+                  <a:tcPr anchor="ctr">
                     <a:lnL w="9525" cap="flat" cmpd="sng" algn="ctr">
                       <a:solidFill>
                         <a:srgbClr val="D5E3E0"/>
@@ -5248,6 +5121,11 @@
                     </a:solidFill>
                   </a:tcPr>
                 </a:tc>
+                <a:extLst>
+                  <a:ext uri="{0D108BD9-81ED-4DB2-BD59-A6C34878D82A}">
+                    <a16:rowId xmlns:a16="http://schemas.microsoft.com/office/drawing/2014/main" val="10005"/>
+                  </a:ext>
+                </a:extLst>
               </a:tr>
               <a:tr h="329184">
                 <a:tc>
@@ -5255,7 +5133,7 @@
                     <a:bodyPr/>
                     <a:lstStyle/>
                     <a:p>
-                      <a:pPr indent="0" marL="0">
+                      <a:pPr marL="0" indent="0">
                         <a:buNone/>
                       </a:pPr>
                       <a:r>
@@ -5276,7 +5154,7 @@
                       </a:endParaRPr>
                     </a:p>
                   </a:txBody>
-                  <a:tcPr marL="91440" marR="91440" marT="45720" marB="45720" anchor="ctr">
+                  <a:tcPr anchor="ctr">
                     <a:lnL w="9525" cap="flat" cmpd="sng" algn="ctr">
                       <a:solidFill>
                         <a:srgbClr val="D5E3E0"/>
@@ -5323,7 +5201,7 @@
                     <a:bodyPr/>
                     <a:lstStyle/>
                     <a:p>
-                      <a:pPr indent="0" marL="0">
+                      <a:pPr marL="0" indent="0">
                         <a:buNone/>
                       </a:pPr>
                       <a:r>
@@ -5344,7 +5222,7 @@
                       </a:endParaRPr>
                     </a:p>
                   </a:txBody>
-                  <a:tcPr marL="91440" marR="91440" marT="45720" marB="45720" anchor="ctr">
+                  <a:tcPr anchor="ctr">
                     <a:lnL w="9525" cap="flat" cmpd="sng" algn="ctr">
                       <a:solidFill>
                         <a:srgbClr val="D5E3E0"/>
@@ -5391,7 +5269,7 @@
                     <a:bodyPr/>
                     <a:lstStyle/>
                     <a:p>
-                      <a:pPr indent="0" marL="0">
+                      <a:pPr marL="0" indent="0">
                         <a:buNone/>
                       </a:pPr>
                       <a:r>
@@ -5412,7 +5290,7 @@
                       </a:endParaRPr>
                     </a:p>
                   </a:txBody>
-                  <a:tcPr marL="91440" marR="91440" marT="45720" marB="45720" anchor="ctr">
+                  <a:tcPr anchor="ctr">
                     <a:lnL w="9525" cap="flat" cmpd="sng" algn="ctr">
                       <a:solidFill>
                         <a:srgbClr val="D5E3E0"/>
@@ -5454,6 +5332,11 @@
                     </a:solidFill>
                   </a:tcPr>
                 </a:tc>
+                <a:extLst>
+                  <a:ext uri="{0D108BD9-81ED-4DB2-BD59-A6C34878D82A}">
+                    <a16:rowId xmlns:a16="http://schemas.microsoft.com/office/drawing/2014/main" val="10006"/>
+                  </a:ext>
+                </a:extLst>
               </a:tr>
             </a:tbl>
           </a:graphicData>
@@ -5480,7 +5363,7 @@
           <a:bodyPr wrap="square" lIns="0" tIns="0" rIns="0" bIns="0" rtlCol="0" anchor="t"/>
           <a:lstStyle/>
           <a:p>
-            <a:pPr indent="0" marL="0">
+            <a:pPr marL="0" indent="0">
               <a:buNone/>
             </a:pPr>
             <a:r>
@@ -5500,7 +5383,7 @@
       </p:sp>
       <p:sp>
         <p:nvSpPr>
-          <p:cNvPr id="5" name="Text 2"/>
+          <p:cNvPr id="3" name="Text 2"/>
           <p:cNvSpPr txBox="1"/>
           <p:nvPr/>
         </p:nvSpPr>
@@ -5519,7 +5402,7 @@
           <a:bodyPr wrap="square" lIns="0" tIns="0" rIns="0" bIns="0" rtlCol="0" anchor="t"/>
           <a:lstStyle/>
           <a:p>
-            <a:pPr indent="0" marL="0">
+            <a:pPr marL="0" indent="0">
               <a:buNone/>
             </a:pPr>
             <a:r>
@@ -5563,7 +5446,7 @@
             <a:prstDash val="solid"/>
           </a:ln>
           <a:effectLst>
-            <a:outerShdw sx="100000" sy="100000" kx="0" ky="0" algn="bl" rotWithShape="0" blurRad="76200" dist="25400" dir="5400000">
+            <a:outerShdw blurRad="76200" dist="25400" dir="5400000" algn="bl" rotWithShape="0">
               <a:srgbClr val="000000">
                 <a:alpha val="12000"/>
               </a:srgbClr>
@@ -5617,7 +5500,7 @@
           <a:bodyPr wrap="square" lIns="0" tIns="0" rIns="0" bIns="0" rtlCol="0" anchor="ctr"/>
           <a:lstStyle/>
           <a:p>
-            <a:pPr algn="ctr" indent="0" marL="0">
+            <a:pPr marL="0" indent="0" algn="ctr">
               <a:buNone/>
             </a:pPr>
             <a:r>
@@ -5656,7 +5539,7 @@
           <a:bodyPr wrap="square" lIns="0" tIns="0" rIns="0" bIns="0" rtlCol="0" anchor="ctr"/>
           <a:lstStyle/>
           <a:p>
-            <a:pPr indent="0" marL="0">
+            <a:pPr marL="0" indent="0">
               <a:buNone/>
             </a:pPr>
             <a:r>
@@ -5700,7 +5583,7 @@
             <a:prstDash val="solid"/>
           </a:ln>
           <a:effectLst>
-            <a:outerShdw sx="100000" sy="100000" kx="0" ky="0" algn="bl" rotWithShape="0" blurRad="76200" dist="25400" dir="5400000">
+            <a:outerShdw blurRad="76200" dist="25400" dir="5400000" algn="bl" rotWithShape="0">
               <a:srgbClr val="000000">
                 <a:alpha val="12000"/>
               </a:srgbClr>
@@ -5754,7 +5637,7 @@
           <a:bodyPr wrap="square" lIns="0" tIns="0" rIns="0" bIns="0" rtlCol="0" anchor="ctr"/>
           <a:lstStyle/>
           <a:p>
-            <a:pPr algn="ctr" indent="0" marL="0">
+            <a:pPr marL="0" indent="0" algn="ctr">
               <a:buNone/>
             </a:pPr>
             <a:r>
@@ -5793,7 +5676,7 @@
           <a:bodyPr wrap="square" lIns="0" tIns="0" rIns="0" bIns="0" rtlCol="0" anchor="ctr"/>
           <a:lstStyle/>
           <a:p>
-            <a:pPr indent="0" marL="0">
+            <a:pPr marL="0" indent="0">
               <a:buNone/>
             </a:pPr>
             <a:r>
@@ -5837,7 +5720,7 @@
             <a:prstDash val="solid"/>
           </a:ln>
           <a:effectLst>
-            <a:outerShdw sx="100000" sy="100000" kx="0" ky="0" algn="bl" rotWithShape="0" blurRad="76200" dist="25400" dir="5400000">
+            <a:outerShdw blurRad="76200" dist="25400" dir="5400000" algn="bl" rotWithShape="0">
               <a:srgbClr val="000000">
                 <a:alpha val="12000"/>
               </a:srgbClr>
@@ -5891,7 +5774,7 @@
           <a:bodyPr wrap="square" lIns="0" tIns="0" rIns="0" bIns="0" rtlCol="0" anchor="ctr"/>
           <a:lstStyle/>
           <a:p>
-            <a:pPr algn="ctr" indent="0" marL="0">
+            <a:pPr marL="0" indent="0" algn="ctr">
               <a:buNone/>
             </a:pPr>
             <a:r>
@@ -5930,7 +5813,7 @@
           <a:bodyPr wrap="square" lIns="0" tIns="0" rIns="0" bIns="0" rtlCol="0" anchor="ctr"/>
           <a:lstStyle/>
           <a:p>
-            <a:pPr indent="0" marL="0">
+            <a:pPr marL="0" indent="0">
               <a:buNone/>
             </a:pPr>
             <a:r>
@@ -5974,7 +5857,7 @@
             <a:prstDash val="solid"/>
           </a:ln>
           <a:effectLst>
-            <a:outerShdw sx="100000" sy="100000" kx="0" ky="0" algn="bl" rotWithShape="0" blurRad="76200" dist="25400" dir="5400000">
+            <a:outerShdw blurRad="76200" dist="25400" dir="5400000" algn="bl" rotWithShape="0">
               <a:srgbClr val="000000">
                 <a:alpha val="12000"/>
               </a:srgbClr>
@@ -6028,7 +5911,7 @@
           <a:bodyPr wrap="square" lIns="0" tIns="0" rIns="0" bIns="0" rtlCol="0" anchor="ctr"/>
           <a:lstStyle/>
           <a:p>
-            <a:pPr algn="ctr" indent="0" marL="0">
+            <a:pPr marL="0" indent="0" algn="ctr">
               <a:buNone/>
             </a:pPr>
             <a:r>
@@ -6067,7 +5950,7 @@
           <a:bodyPr wrap="square" lIns="0" tIns="0" rIns="0" bIns="0" rtlCol="0" anchor="ctr"/>
           <a:lstStyle/>
           <a:p>
-            <a:pPr indent="0" marL="0">
+            <a:pPr marL="0" indent="0">
               <a:buNone/>
             </a:pPr>
             <a:r>
@@ -6101,6 +5984,7 @@
         <a:solidFill>
           <a:srgbClr val="EAF5F3"/>
         </a:solidFill>
+        <a:effectLst/>
       </p:bgPr>
     </p:bg>
     <p:spTree>
@@ -6138,7 +6022,7 @@
           <a:bodyPr wrap="square" lIns="0" tIns="0" rIns="0" bIns="0" rtlCol="0" anchor="ctr"/>
           <a:lstStyle/>
           <a:p>
-            <a:pPr indent="0" marL="0">
+            <a:pPr marL="0" indent="0">
               <a:buNone/>
             </a:pPr>
             <a:r>
@@ -6177,7 +6061,7 @@
           <a:bodyPr wrap="square" lIns="0" tIns="0" rIns="0" bIns="0" rtlCol="0" anchor="t"/>
           <a:lstStyle/>
           <a:p>
-            <a:pPr indent="0" marL="0">
+            <a:pPr marL="0" indent="0">
               <a:buNone/>
             </a:pPr>
             <a:r>
@@ -6221,7 +6105,7 @@
             <a:prstDash val="solid"/>
           </a:ln>
           <a:effectLst>
-            <a:outerShdw sx="100000" sy="100000" kx="0" ky="0" algn="bl" rotWithShape="0" blurRad="76200" dist="25400" dir="5400000">
+            <a:outerShdw blurRad="76200" dist="25400" dir="5400000" algn="bl" rotWithShape="0">
               <a:srgbClr val="000000">
                 <a:alpha val="12000"/>
               </a:srgbClr>
@@ -6275,7 +6159,7 @@
           <a:bodyPr wrap="square" lIns="0" tIns="0" rIns="0" bIns="0" rtlCol="0" anchor="ctr"/>
           <a:lstStyle/>
           <a:p>
-            <a:pPr algn="ctr" indent="0" marL="0">
+            <a:pPr marL="0" indent="0" algn="ctr">
               <a:buNone/>
             </a:pPr>
             <a:r>
@@ -6314,7 +6198,7 @@
           <a:bodyPr wrap="square" lIns="0" tIns="0" rIns="0" bIns="0" rtlCol="0" anchor="ctr"/>
           <a:lstStyle/>
           <a:p>
-            <a:pPr indent="0" marL="0">
+            <a:pPr marL="0" indent="0">
               <a:buNone/>
             </a:pPr>
             <a:r>
@@ -6358,7 +6242,7 @@
             <a:prstDash val="solid"/>
           </a:ln>
           <a:effectLst>
-            <a:outerShdw sx="100000" sy="100000" kx="0" ky="0" algn="bl" rotWithShape="0" blurRad="76200" dist="25400" dir="5400000">
+            <a:outerShdw blurRad="76200" dist="25400" dir="5400000" algn="bl" rotWithShape="0">
               <a:srgbClr val="000000">
                 <a:alpha val="12000"/>
               </a:srgbClr>
@@ -6412,7 +6296,7 @@
           <a:bodyPr wrap="square" lIns="0" tIns="0" rIns="0" bIns="0" rtlCol="0" anchor="ctr"/>
           <a:lstStyle/>
           <a:p>
-            <a:pPr algn="ctr" indent="0" marL="0">
+            <a:pPr marL="0" indent="0" algn="ctr">
               <a:buNone/>
             </a:pPr>
             <a:r>
@@ -6451,7 +6335,7 @@
           <a:bodyPr wrap="square" lIns="0" tIns="0" rIns="0" bIns="0" rtlCol="0" anchor="ctr"/>
           <a:lstStyle/>
           <a:p>
-            <a:pPr indent="0" marL="0">
+            <a:pPr marL="0" indent="0">
               <a:buNone/>
             </a:pPr>
             <a:r>
@@ -6495,7 +6379,7 @@
             <a:prstDash val="solid"/>
           </a:ln>
           <a:effectLst>
-            <a:outerShdw sx="100000" sy="100000" kx="0" ky="0" algn="bl" rotWithShape="0" blurRad="76200" dist="25400" dir="5400000">
+            <a:outerShdw blurRad="76200" dist="25400" dir="5400000" algn="bl" rotWithShape="0">
               <a:srgbClr val="000000">
                 <a:alpha val="12000"/>
               </a:srgbClr>
@@ -6549,7 +6433,7 @@
           <a:bodyPr wrap="square" lIns="0" tIns="0" rIns="0" bIns="0" rtlCol="0" anchor="ctr"/>
           <a:lstStyle/>
           <a:p>
-            <a:pPr algn="ctr" indent="0" marL="0">
+            <a:pPr marL="0" indent="0" algn="ctr">
               <a:buNone/>
             </a:pPr>
             <a:r>
@@ -6588,7 +6472,7 @@
           <a:bodyPr wrap="square" lIns="0" tIns="0" rIns="0" bIns="0" rtlCol="0" anchor="ctr"/>
           <a:lstStyle/>
           <a:p>
-            <a:pPr indent="0" marL="0">
+            <a:pPr marL="0" indent="0">
               <a:buNone/>
             </a:pPr>
             <a:r>
@@ -6632,7 +6516,7 @@
             <a:prstDash val="solid"/>
           </a:ln>
           <a:effectLst>
-            <a:outerShdw sx="100000" sy="100000" kx="0" ky="0" algn="bl" rotWithShape="0" blurRad="76200" dist="25400" dir="5400000">
+            <a:outerShdw blurRad="76200" dist="25400" dir="5400000" algn="bl" rotWithShape="0">
               <a:srgbClr val="000000">
                 <a:alpha val="12000"/>
               </a:srgbClr>
@@ -6686,7 +6570,7 @@
           <a:bodyPr wrap="square" lIns="0" tIns="0" rIns="0" bIns="0" rtlCol="0" anchor="ctr"/>
           <a:lstStyle/>
           <a:p>
-            <a:pPr algn="ctr" indent="0" marL="0">
+            <a:pPr marL="0" indent="0" algn="ctr">
               <a:buNone/>
             </a:pPr>
             <a:r>
@@ -6725,7 +6609,7 @@
           <a:bodyPr wrap="square" lIns="0" tIns="0" rIns="0" bIns="0" rtlCol="0" anchor="ctr"/>
           <a:lstStyle/>
           <a:p>
-            <a:pPr indent="0" marL="0">
+            <a:pPr marL="0" indent="0">
               <a:buNone/>
             </a:pPr>
             <a:r>
@@ -6769,7 +6653,7 @@
             <a:prstDash val="solid"/>
           </a:ln>
           <a:effectLst>
-            <a:outerShdw sx="100000" sy="100000" kx="0" ky="0" algn="bl" rotWithShape="0" blurRad="76200" dist="25400" dir="5400000">
+            <a:outerShdw blurRad="76200" dist="25400" dir="5400000" algn="bl" rotWithShape="0">
               <a:srgbClr val="000000">
                 <a:alpha val="12000"/>
               </a:srgbClr>
@@ -6823,7 +6707,7 @@
           <a:bodyPr wrap="square" lIns="0" tIns="0" rIns="0" bIns="0" rtlCol="0" anchor="ctr"/>
           <a:lstStyle/>
           <a:p>
-            <a:pPr algn="ctr" indent="0" marL="0">
+            <a:pPr marL="0" indent="0" algn="ctr">
               <a:buNone/>
             </a:pPr>
             <a:r>
@@ -6862,7 +6746,7 @@
           <a:bodyPr wrap="square" lIns="0" tIns="0" rIns="0" bIns="0" rtlCol="0" anchor="ctr"/>
           <a:lstStyle/>
           <a:p>
-            <a:pPr indent="0" marL="0">
+            <a:pPr marL="0" indent="0">
               <a:buNone/>
             </a:pPr>
             <a:r>
@@ -6906,7 +6790,7 @@
             <a:prstDash val="solid"/>
           </a:ln>
           <a:effectLst>
-            <a:outerShdw sx="100000" sy="100000" kx="0" ky="0" algn="bl" rotWithShape="0" blurRad="76200" dist="25400" dir="5400000">
+            <a:outerShdw blurRad="76200" dist="25400" dir="5400000" algn="bl" rotWithShape="0">
               <a:srgbClr val="000000">
                 <a:alpha val="12000"/>
               </a:srgbClr>
@@ -6960,7 +6844,7 @@
           <a:bodyPr wrap="square" lIns="0" tIns="0" rIns="0" bIns="0" rtlCol="0" anchor="ctr"/>
           <a:lstStyle/>
           <a:p>
-            <a:pPr algn="ctr" indent="0" marL="0">
+            <a:pPr marL="0" indent="0" algn="ctr">
               <a:buNone/>
             </a:pPr>
             <a:r>
@@ -6999,7 +6883,7 @@
           <a:bodyPr wrap="square" lIns="0" tIns="0" rIns="0" bIns="0" rtlCol="0" anchor="ctr"/>
           <a:lstStyle/>
           <a:p>
-            <a:pPr indent="0" marL="0">
+            <a:pPr marL="0" indent="0">
               <a:buNone/>
             </a:pPr>
             <a:r>
@@ -7038,7 +6922,7 @@
           <a:bodyPr wrap="square" lIns="0" tIns="0" rIns="0" bIns="0" rtlCol="0" anchor="t"/>
           <a:lstStyle/>
           <a:p>
-            <a:pPr indent="0" marL="0">
+            <a:pPr marL="0" indent="0">
               <a:buNone/>
             </a:pPr>
             <a:r>
@@ -7082,7 +6966,7 @@
             <a:prstDash val="solid"/>
           </a:ln>
           <a:effectLst>
-            <a:outerShdw sx="100000" sy="100000" kx="0" ky="0" algn="bl" rotWithShape="0" blurRad="76200" dist="25400" dir="5400000">
+            <a:outerShdw blurRad="76200" dist="25400" dir="5400000" algn="bl" rotWithShape="0">
               <a:srgbClr val="000000">
                 <a:alpha val="12000"/>
               </a:srgbClr>
@@ -7111,7 +6995,7 @@
           <a:bodyPr wrap="square" lIns="0" tIns="0" rIns="0" bIns="0" rtlCol="0" anchor="t"/>
           <a:lstStyle/>
           <a:p>
-            <a:pPr algn="ctr" indent="0" marL="0">
+            <a:pPr marL="0" indent="0" algn="ctr">
               <a:buNone/>
             </a:pPr>
             <a:r>
@@ -7150,7 +7034,7 @@
           <a:bodyPr wrap="square" lIns="0" tIns="0" rIns="0" bIns="0" rtlCol="0" anchor="t"/>
           <a:lstStyle/>
           <a:p>
-            <a:pPr algn="ctr" indent="0" marL="0">
+            <a:pPr marL="0" indent="0" algn="ctr">
               <a:buNone/>
             </a:pPr>
             <a:r>
@@ -7194,7 +7078,7 @@
             <a:prstDash val="solid"/>
           </a:ln>
           <a:effectLst>
-            <a:outerShdw sx="100000" sy="100000" kx="0" ky="0" algn="bl" rotWithShape="0" blurRad="76200" dist="25400" dir="5400000">
+            <a:outerShdw blurRad="76200" dist="25400" dir="5400000" algn="bl" rotWithShape="0">
               <a:srgbClr val="000000">
                 <a:alpha val="12000"/>
               </a:srgbClr>
@@ -7223,7 +7107,7 @@
           <a:bodyPr wrap="square" lIns="0" tIns="0" rIns="0" bIns="0" rtlCol="0" anchor="t"/>
           <a:lstStyle/>
           <a:p>
-            <a:pPr algn="ctr" indent="0" marL="0">
+            <a:pPr marL="0" indent="0" algn="ctr">
               <a:buNone/>
             </a:pPr>
             <a:r>
@@ -7262,7 +7146,7 @@
           <a:bodyPr wrap="square" lIns="0" tIns="0" rIns="0" bIns="0" rtlCol="0" anchor="t"/>
           <a:lstStyle/>
           <a:p>
-            <a:pPr algn="ctr" indent="0" marL="0">
+            <a:pPr marL="0" indent="0" algn="ctr">
               <a:buNone/>
             </a:pPr>
             <a:r>
@@ -7328,7 +7212,7 @@
           <a:bodyPr wrap="square" lIns="0" tIns="0" rIns="0" bIns="0" rtlCol="0" anchor="t"/>
           <a:lstStyle/>
           <a:p>
-            <a:pPr algn="ctr" indent="0" marL="0">
+            <a:pPr marL="0" indent="0" algn="ctr">
               <a:buNone/>
             </a:pPr>
             <a:r>
@@ -7367,7 +7251,7 @@
           <a:bodyPr wrap="square" lIns="0" tIns="0" rIns="0" bIns="0" rtlCol="0" anchor="t"/>
           <a:lstStyle/>
           <a:p>
-            <a:pPr algn="ctr" indent="0" marL="0">
+            <a:pPr marL="0" indent="0" algn="ctr">
               <a:buNone/>
             </a:pPr>
             <a:r>
@@ -7406,7 +7290,7 @@
           <a:bodyPr wrap="square" lIns="0" tIns="0" rIns="0" bIns="0" rtlCol="0" anchor="t"/>
           <a:lstStyle/>
           <a:p>
-            <a:pPr indent="0" marL="0">
+            <a:pPr marL="0" indent="0">
               <a:buNone/>
             </a:pPr>
             <a:r>
@@ -7440,6 +7324,7 @@
         <a:solidFill>
           <a:srgbClr val="EAF5F3"/>
         </a:solidFill>
+        <a:effectLst/>
       </p:bgPr>
     </p:bg>
     <p:spTree>
@@ -7477,7 +7362,7 @@
           <a:bodyPr wrap="square" lIns="0" tIns="0" rIns="0" bIns="0" rtlCol="0" anchor="ctr"/>
           <a:lstStyle/>
           <a:p>
-            <a:pPr indent="0" marL="0">
+            <a:pPr marL="0" indent="0">
               <a:buNone/>
             </a:pPr>
             <a:r>
@@ -7521,7 +7406,7 @@
             <a:prstDash val="solid"/>
           </a:ln>
           <a:effectLst>
-            <a:outerShdw sx="100000" sy="100000" kx="0" ky="0" algn="bl" rotWithShape="0" blurRad="76200" dist="25400" dir="5400000">
+            <a:outerShdw blurRad="76200" dist="25400" dir="5400000" algn="bl" rotWithShape="0">
               <a:srgbClr val="000000">
                 <a:alpha val="12000"/>
               </a:srgbClr>
@@ -7550,7 +7435,7 @@
           <a:bodyPr wrap="square" lIns="0" tIns="0" rIns="0" bIns="0" rtlCol="0" anchor="t"/>
           <a:lstStyle/>
           <a:p>
-            <a:pPr indent="0" marL="0">
+            <a:pPr marL="0" indent="0">
               <a:buNone/>
             </a:pPr>
             <a:r>
@@ -7589,7 +7474,7 @@
           <a:bodyPr wrap="square" lIns="0" tIns="0" rIns="0" bIns="0" rtlCol="0" anchor="t"/>
           <a:lstStyle/>
           <a:p>
-            <a:pPr indent="0" marL="0">
+            <a:pPr marL="0" indent="0">
               <a:buNone/>
             </a:pPr>
             <a:r>
@@ -7633,7 +7518,7 @@
             <a:prstDash val="solid"/>
           </a:ln>
           <a:effectLst>
-            <a:outerShdw sx="100000" sy="100000" kx="0" ky="0" algn="bl" rotWithShape="0" blurRad="76200" dist="25400" dir="5400000">
+            <a:outerShdw blurRad="76200" dist="25400" dir="5400000" algn="bl" rotWithShape="0">
               <a:srgbClr val="000000">
                 <a:alpha val="12000"/>
               </a:srgbClr>
@@ -7662,7 +7547,7 @@
           <a:bodyPr wrap="square" lIns="0" tIns="0" rIns="0" bIns="0" rtlCol="0" anchor="t"/>
           <a:lstStyle/>
           <a:p>
-            <a:pPr indent="0" marL="0">
+            <a:pPr marL="0" indent="0">
               <a:buNone/>
             </a:pPr>
             <a:r>
@@ -7701,7 +7586,7 @@
           <a:bodyPr wrap="square" lIns="0" tIns="0" rIns="0" bIns="0" rtlCol="0" anchor="t"/>
           <a:lstStyle/>
           <a:p>
-            <a:pPr indent="0" marL="0">
+            <a:pPr marL="0" indent="0">
               <a:buNone/>
             </a:pPr>
             <a:r>
@@ -7745,7 +7630,7 @@
             <a:prstDash val="solid"/>
           </a:ln>
           <a:effectLst>
-            <a:outerShdw sx="100000" sy="100000" kx="0" ky="0" algn="bl" rotWithShape="0" blurRad="76200" dist="25400" dir="5400000">
+            <a:outerShdw blurRad="76200" dist="25400" dir="5400000" algn="bl" rotWithShape="0">
               <a:srgbClr val="000000">
                 <a:alpha val="12000"/>
               </a:srgbClr>
@@ -7774,7 +7659,7 @@
           <a:bodyPr wrap="square" lIns="0" tIns="0" rIns="0" bIns="0" rtlCol="0" anchor="t"/>
           <a:lstStyle/>
           <a:p>
-            <a:pPr indent="0" marL="0">
+            <a:pPr marL="0" indent="0">
               <a:buNone/>
             </a:pPr>
             <a:r>
@@ -7813,7 +7698,7 @@
           <a:bodyPr wrap="square" lIns="0" tIns="0" rIns="0" bIns="0" rtlCol="0" anchor="t"/>
           <a:lstStyle/>
           <a:p>
-            <a:pPr indent="0" marL="0">
+            <a:pPr marL="0" indent="0">
               <a:buNone/>
             </a:pPr>
             <a:r>
@@ -7857,7 +7742,7 @@
             <a:prstDash val="solid"/>
           </a:ln>
           <a:effectLst>
-            <a:outerShdw sx="100000" sy="100000" kx="0" ky="0" algn="bl" rotWithShape="0" blurRad="76200" dist="25400" dir="5400000">
+            <a:outerShdw blurRad="76200" dist="25400" dir="5400000" algn="bl" rotWithShape="0">
               <a:srgbClr val="000000">
                 <a:alpha val="12000"/>
               </a:srgbClr>
@@ -7886,7 +7771,7 @@
           <a:bodyPr wrap="square" lIns="0" tIns="0" rIns="0" bIns="0" rtlCol="0" anchor="t"/>
           <a:lstStyle/>
           <a:p>
-            <a:pPr indent="0" marL="0">
+            <a:pPr marL="0" indent="0">
               <a:buNone/>
             </a:pPr>
             <a:r>
@@ -7925,7 +7810,7 @@
           <a:bodyPr wrap="square" lIns="0" tIns="0" rIns="0" bIns="0" rtlCol="0" anchor="t"/>
           <a:lstStyle/>
           <a:p>
-            <a:pPr indent="0" marL="0">
+            <a:pPr marL="0" indent="0">
               <a:buNone/>
             </a:pPr>
             <a:r>
@@ -7964,7 +7849,7 @@
           <a:bodyPr wrap="square" lIns="0" tIns="0" rIns="0" bIns="0" rtlCol="0" anchor="t"/>
           <a:lstStyle/>
           <a:p>
-            <a:pPr indent="0" marL="0">
+            <a:pPr marL="0" indent="0">
               <a:buNone/>
             </a:pPr>
             <a:r>
@@ -8030,7 +7915,7 @@
           <a:bodyPr wrap="square" lIns="0" tIns="0" rIns="0" bIns="0" rtlCol="0" anchor="ctr"/>
           <a:lstStyle/>
           <a:p>
-            <a:pPr indent="0" marL="0">
+            <a:pPr marL="0" indent="0">
               <a:buNone/>
             </a:pPr>
             <a:r>
@@ -8074,7 +7959,7 @@
             <a:prstDash val="solid"/>
           </a:ln>
           <a:effectLst>
-            <a:outerShdw sx="100000" sy="100000" kx="0" ky="0" algn="bl" rotWithShape="0" blurRad="76200" dist="25400" dir="5400000">
+            <a:outerShdw blurRad="76200" dist="25400" dir="5400000" algn="bl" rotWithShape="0">
               <a:srgbClr val="000000">
                 <a:alpha val="12000"/>
               </a:srgbClr>
@@ -8103,7 +7988,7 @@
           <a:bodyPr wrap="square" lIns="0" tIns="0" rIns="0" bIns="0" rtlCol="0" anchor="ctr"/>
           <a:lstStyle/>
           <a:p>
-            <a:pPr indent="0" marL="0">
+            <a:pPr marL="0" indent="0">
               <a:buNone/>
             </a:pPr>
             <a:r>
@@ -8169,7 +8054,7 @@
           <a:bodyPr wrap="square" lIns="0" tIns="0" rIns="0" bIns="0" rtlCol="0" anchor="ctr"/>
           <a:lstStyle/>
           <a:p>
-            <a:pPr indent="0" marL="0">
+            <a:pPr marL="0" indent="0">
               <a:buNone/>
             </a:pPr>
             <a:r>
@@ -8213,7 +8098,7 @@
             <a:prstDash val="solid"/>
           </a:ln>
           <a:effectLst>
-            <a:outerShdw sx="100000" sy="100000" kx="0" ky="0" algn="bl" rotWithShape="0" blurRad="76200" dist="25400" dir="5400000">
+            <a:outerShdw blurRad="76200" dist="25400" dir="5400000" algn="bl" rotWithShape="0">
               <a:srgbClr val="000000">
                 <a:alpha val="12000"/>
               </a:srgbClr>
@@ -8242,7 +8127,7 @@
           <a:bodyPr wrap="square" lIns="0" tIns="0" rIns="0" bIns="0" rtlCol="0" anchor="ctr"/>
           <a:lstStyle/>
           <a:p>
-            <a:pPr indent="0" marL="0">
+            <a:pPr marL="0" indent="0">
               <a:buNone/>
             </a:pPr>
             <a:r>
@@ -8276,6 +8161,7 @@
         <a:solidFill>
           <a:srgbClr val="EAF5F3"/>
         </a:solidFill>
+        <a:effectLst/>
       </p:bgPr>
     </p:bg>
     <p:spTree>
@@ -8313,7 +8199,7 @@
           <a:bodyPr wrap="square" lIns="0" tIns="0" rIns="0" bIns="0" rtlCol="0" anchor="ctr"/>
           <a:lstStyle/>
           <a:p>
-            <a:pPr indent="0" marL="0">
+            <a:pPr marL="0" indent="0">
               <a:buNone/>
             </a:pPr>
             <a:r>
@@ -8333,14 +8219,14 @@
       </p:sp>
       <p:pic>
         <p:nvPicPr>
-          <p:cNvPr id="3" name="Image 0" descr="/mnt/user-data/uploads/1790688904731_image.png">    </p:cNvPr>
+          <p:cNvPr id="3" name="Image 0" descr="/mnt/user-data/uploads/1790688904731_image.png"/>
           <p:cNvPicPr>
             <a:picLocks noChangeAspect="1"/>
           </p:cNvPicPr>
           <p:nvPr/>
         </p:nvPicPr>
         <p:blipFill>
-          <a:blip r:embed="rId1"/>
+          <a:blip r:embed="rId3"/>
           <a:stretch>
             <a:fillRect/>
           </a:stretch>
@@ -8354,7 +8240,7 @@
             <a:avLst/>
           </a:prstGeom>
           <a:effectLst>
-            <a:outerShdw sx="100000" sy="100000" kx="0" ky="0" algn="bl" rotWithShape="0" blurRad="76200" dist="25400" dir="5400000">
+            <a:outerShdw blurRad="76200" dist="25400" dir="5400000" algn="bl" rotWithShape="0">
               <a:srgbClr val="000000">
                 <a:alpha val="12000"/>
               </a:srgbClr>
@@ -8388,7 +8274,7 @@
             <a:prstDash val="solid"/>
           </a:ln>
           <a:effectLst>
-            <a:outerShdw sx="100000" sy="100000" kx="0" ky="0" algn="bl" rotWithShape="0" blurRad="76200" dist="25400" dir="5400000">
+            <a:outerShdw blurRad="76200" dist="25400" dir="5400000" algn="bl" rotWithShape="0">
               <a:srgbClr val="000000">
                 <a:alpha val="12000"/>
               </a:srgbClr>
@@ -8417,7 +8303,7 @@
           <a:bodyPr wrap="square" lIns="0" tIns="0" rIns="0" bIns="0" rtlCol="0" anchor="t"/>
           <a:lstStyle/>
           <a:p>
-            <a:pPr indent="0" marL="0">
+            <a:pPr marL="0" indent="0">
               <a:buNone/>
             </a:pPr>
             <a:r>
@@ -8456,7 +8342,7 @@
           <a:bodyPr wrap="square" lIns="0" tIns="0" rIns="0" bIns="0" rtlCol="0" anchor="t"/>
           <a:lstStyle/>
           <a:p>
-            <a:pPr indent="0" marL="0">
+            <a:pPr marL="0" indent="0">
               <a:buNone/>
             </a:pPr>
             <a:r>
@@ -8500,7 +8386,7 @@
             <a:prstDash val="solid"/>
           </a:ln>
           <a:effectLst>
-            <a:outerShdw sx="100000" sy="100000" kx="0" ky="0" algn="bl" rotWithShape="0" blurRad="76200" dist="25400" dir="5400000">
+            <a:outerShdw blurRad="76200" dist="25400" dir="5400000" algn="bl" rotWithShape="0">
               <a:srgbClr val="000000">
                 <a:alpha val="12000"/>
               </a:srgbClr>
@@ -8529,7 +8415,7 @@
           <a:bodyPr wrap="square" lIns="0" tIns="0" rIns="0" bIns="0" rtlCol="0" anchor="t"/>
           <a:lstStyle/>
           <a:p>
-            <a:pPr indent="0" marL="0">
+            <a:pPr marL="0" indent="0">
               <a:buNone/>
             </a:pPr>
             <a:r>
@@ -8568,7 +8454,7 @@
           <a:bodyPr wrap="square" lIns="0" tIns="0" rIns="0" bIns="0" rtlCol="0" anchor="t"/>
           <a:lstStyle/>
           <a:p>
-            <a:pPr indent="0" marL="0">
+            <a:pPr marL="0" indent="0">
               <a:buNone/>
             </a:pPr>
             <a:r>
@@ -8612,7 +8498,7 @@
             <a:prstDash val="solid"/>
           </a:ln>
           <a:effectLst>
-            <a:outerShdw sx="100000" sy="100000" kx="0" ky="0" algn="bl" rotWithShape="0" blurRad="76200" dist="25400" dir="5400000">
+            <a:outerShdw blurRad="76200" dist="25400" dir="5400000" algn="bl" rotWithShape="0">
               <a:srgbClr val="000000">
                 <a:alpha val="12000"/>
               </a:srgbClr>
@@ -8641,7 +8527,7 @@
           <a:bodyPr wrap="square" lIns="0" tIns="0" rIns="0" bIns="0" rtlCol="0" anchor="t"/>
           <a:lstStyle/>
           <a:p>
-            <a:pPr indent="0" marL="0">
+            <a:pPr marL="0" indent="0">
               <a:buNone/>
             </a:pPr>
             <a:r>
@@ -8680,7 +8566,7 @@
           <a:bodyPr wrap="square" lIns="0" tIns="0" rIns="0" bIns="0" rtlCol="0" anchor="t"/>
           <a:lstStyle/>
           <a:p>
-            <a:pPr indent="0" marL="0">
+            <a:pPr marL="0" indent="0">
               <a:buNone/>
             </a:pPr>
             <a:r>
@@ -8724,7 +8610,7 @@
             <a:prstDash val="solid"/>
           </a:ln>
           <a:effectLst>
-            <a:outerShdw sx="100000" sy="100000" kx="0" ky="0" algn="bl" rotWithShape="0" blurRad="76200" dist="25400" dir="5400000">
+            <a:outerShdw blurRad="76200" dist="25400" dir="5400000" algn="bl" rotWithShape="0">
               <a:srgbClr val="000000">
                 <a:alpha val="12000"/>
               </a:srgbClr>
@@ -8753,7 +8639,7 @@
           <a:bodyPr wrap="square" lIns="0" tIns="0" rIns="0" bIns="0" rtlCol="0" anchor="t"/>
           <a:lstStyle/>
           <a:p>
-            <a:pPr indent="0" marL="0">
+            <a:pPr marL="0" indent="0">
               <a:buNone/>
             </a:pPr>
             <a:r>
@@ -8792,7 +8678,7 @@
           <a:bodyPr wrap="square" lIns="0" tIns="0" rIns="0" bIns="0" rtlCol="0" anchor="t"/>
           <a:lstStyle/>
           <a:p>
-            <a:pPr indent="0" marL="0">
+            <a:pPr marL="0" indent="0">
               <a:buNone/>
             </a:pPr>
             <a:r>
@@ -8826,6 +8712,7 @@
         <a:solidFill>
           <a:srgbClr val="0E2A36"/>
         </a:solidFill>
+        <a:effectLst/>
       </p:bgPr>
     </p:bg>
     <p:spTree>
@@ -8863,7 +8750,7 @@
           <a:bodyPr wrap="square" lIns="0" tIns="0" rIns="0" bIns="0" rtlCol="0" anchor="ctr"/>
           <a:lstStyle/>
           <a:p>
-            <a:pPr indent="0" marL="0">
+            <a:pPr marL="0" indent="0">
               <a:buNone/>
             </a:pPr>
             <a:r>
@@ -8875,7 +8762,7 @@
                 <a:ea typeface="Cambria" pitchFamily="34" charset="-122"/>
                 <a:cs typeface="Cambria" pitchFamily="34" charset="-120"/>
               </a:rPr>
-              <a:t>Verified today, Raft next</a:t>
+              <a:t>Installation &amp; What’s next?</a:t>
             </a:r>
             <a:endParaRPr lang="en-US" sz="2800" dirty="0"/>
           </a:p>
@@ -8883,18 +8770,18 @@
       </p:sp>
       <p:sp>
         <p:nvSpPr>
-          <p:cNvPr id="3" name="Shape 1"/>
+          <p:cNvPr id="12" name="Shape 10"/>
           <p:cNvSpPr/>
           <p:nvPr/>
         </p:nvSpPr>
         <p:spPr>
           <a:xfrm>
-            <a:off x="457200" y="1097280"/>
-            <a:ext cx="2651760" cy="1143000"/>
+            <a:off x="457200" y="1705707"/>
+            <a:ext cx="4023360" cy="2011680"/>
           </a:xfrm>
           <a:prstGeom prst="roundRect">
             <a:avLst>
-              <a:gd name="adj" fmla="val 6400"/>
+              <a:gd name="adj" fmla="val 3636"/>
             </a:avLst>
           </a:prstGeom>
           <a:solidFill>
@@ -8910,96 +8797,187 @@
       </p:sp>
       <p:sp>
         <p:nvSpPr>
-          <p:cNvPr id="4" name="Text 2"/>
-          <p:cNvSpPr txBox="1"/>
-          <p:nvPr/>
-        </p:nvSpPr>
-        <p:spPr>
-          <a:xfrm>
-            <a:off x="640080" y="1170432"/>
-            <a:ext cx="1371600" cy="731520"/>
-          </a:xfrm>
-          <a:prstGeom prst="rect">
-            <a:avLst/>
-          </a:prstGeom>
-          <a:noFill/>
-          <a:ln/>
-        </p:spPr>
-        <p:txBody>
-          <a:bodyPr wrap="square" lIns="0" tIns="0" rIns="0" bIns="0" rtlCol="0" anchor="ctr"/>
-          <a:lstStyle/>
-          <a:p>
-            <a:pPr indent="0" marL="0">
-              <a:buNone/>
-            </a:pPr>
-            <a:r>
-              <a:rPr lang="en-US" sz="3600" b="1" dirty="0">
+          <p:cNvPr id="13" name="Text 11"/>
+          <p:cNvSpPr txBox="1"/>
+          <p:nvPr/>
+        </p:nvSpPr>
+        <p:spPr>
+          <a:xfrm>
+            <a:off x="640080" y="1815435"/>
+            <a:ext cx="2743200" cy="228600"/>
+          </a:xfrm>
+          <a:prstGeom prst="rect">
+            <a:avLst/>
+          </a:prstGeom>
+          <a:noFill/>
+          <a:ln/>
+        </p:spPr>
+        <p:txBody>
+          <a:bodyPr wrap="square" lIns="0" tIns="0" rIns="0" bIns="0" rtlCol="0" anchor="t"/>
+          <a:lstStyle/>
+          <a:p>
+            <a:pPr marL="0" indent="0">
+              <a:buNone/>
+            </a:pPr>
+            <a:r>
+              <a:rPr lang="en-US" sz="1100" b="1" dirty="0">
                 <a:solidFill>
                   <a:srgbClr val="F2A541"/>
                 </a:solidFill>
-                <a:latin typeface="Cambria" pitchFamily="34" charset="0"/>
-                <a:ea typeface="Cambria" pitchFamily="34" charset="-122"/>
-                <a:cs typeface="Cambria" pitchFamily="34" charset="-120"/>
-              </a:rPr>
-              <a:t>13/13</a:t>
-            </a:r>
-            <a:endParaRPr lang="en-US" sz="3600" dirty="0"/>
-          </a:p>
-        </p:txBody>
-      </p:sp>
-      <p:sp>
-        <p:nvSpPr>
-          <p:cNvPr id="5" name="Text 3"/>
-          <p:cNvSpPr txBox="1"/>
-          <p:nvPr/>
-        </p:nvSpPr>
-        <p:spPr>
-          <a:xfrm>
-            <a:off x="1874520" y="1170432"/>
-            <a:ext cx="1143000" cy="731520"/>
-          </a:xfrm>
-          <a:prstGeom prst="rect">
-            <a:avLst/>
-          </a:prstGeom>
-          <a:noFill/>
-          <a:ln/>
-        </p:spPr>
-        <p:txBody>
-          <a:bodyPr wrap="square" lIns="0" tIns="0" rIns="0" bIns="0" rtlCol="0" anchor="ctr"/>
-          <a:lstStyle/>
-          <a:p>
-            <a:pPr indent="0" marL="0">
-              <a:buNone/>
-            </a:pPr>
-            <a:r>
-              <a:rPr lang="en-US" sz="1100" dirty="0">
+                <a:latin typeface="Calibri" pitchFamily="34" charset="0"/>
+                <a:ea typeface="Calibri" pitchFamily="34" charset="-122"/>
+                <a:cs typeface="Calibri" pitchFamily="34" charset="-120"/>
+              </a:rPr>
+              <a:t>RUN IT</a:t>
+            </a:r>
+            <a:endParaRPr lang="en-US" sz="1100" dirty="0"/>
+          </a:p>
+        </p:txBody>
+      </p:sp>
+      <p:sp>
+        <p:nvSpPr>
+          <p:cNvPr id="14" name="Text 12"/>
+          <p:cNvSpPr txBox="1"/>
+          <p:nvPr/>
+        </p:nvSpPr>
+        <p:spPr>
+          <a:xfrm>
+            <a:off x="640080" y="2117187"/>
+            <a:ext cx="3657600" cy="1463040"/>
+          </a:xfrm>
+          <a:prstGeom prst="rect">
+            <a:avLst/>
+          </a:prstGeom>
+          <a:noFill/>
+          <a:ln/>
+        </p:spPr>
+        <p:txBody>
+          <a:bodyPr wrap="square" lIns="0" tIns="0" rIns="0" bIns="0" rtlCol="0" anchor="t"/>
+          <a:lstStyle/>
+          <a:p>
+            <a:pPr marL="0" indent="0">
+              <a:buNone/>
+            </a:pPr>
+            <a:r>
+              <a:rPr lang="en-US" sz="1050" dirty="0">
                 <a:solidFill>
                   <a:srgbClr val="FFFFFF"/>
                 </a:solidFill>
-                <a:latin typeface="Calibri" pitchFamily="34" charset="0"/>
-                <a:ea typeface="Calibri" pitchFamily="34" charset="-122"/>
-                <a:cs typeface="Calibri" pitchFamily="34" charset="-120"/>
-              </a:rPr>
-              <a:t>unit tests passing</a:t>
-            </a:r>
-            <a:endParaRPr lang="en-US" sz="1100" dirty="0"/>
-          </a:p>
-        </p:txBody>
-      </p:sp>
-      <p:sp>
-        <p:nvSpPr>
-          <p:cNvPr id="6" name="Shape 4"/>
+                <a:latin typeface="Courier New" pitchFamily="34" charset="0"/>
+                <a:ea typeface="Courier New" pitchFamily="34" charset="-122"/>
+                <a:cs typeface="Courier New" pitchFamily="34" charset="-120"/>
+              </a:rPr>
+              <a:t>pip install -e .</a:t>
+            </a:r>
+            <a:endParaRPr lang="en-US" sz="1050" dirty="0"/>
+          </a:p>
+          <a:p>
+            <a:pPr marL="0" indent="0">
+              <a:buNone/>
+            </a:pPr>
+            <a:r>
+              <a:rPr lang="en-US" sz="1050" dirty="0">
+                <a:solidFill>
+                  <a:srgbClr val="FFFFFF"/>
+                </a:solidFill>
+                <a:latin typeface="Courier New" pitchFamily="34" charset="0"/>
+                <a:ea typeface="Courier New" pitchFamily="34" charset="-122"/>
+                <a:cs typeface="Courier New" pitchFamily="34" charset="-120"/>
+              </a:rPr>
+              <a:t>python scripts/run_all_demo.py</a:t>
+            </a:r>
+            <a:endParaRPr lang="en-US" sz="1050" dirty="0"/>
+          </a:p>
+          <a:p>
+            <a:pPr marL="0" indent="0">
+              <a:buNone/>
+            </a:pPr>
+            <a:endParaRPr lang="en-US" sz="1050" dirty="0"/>
+          </a:p>
+          <a:p>
+            <a:pPr marL="0" indent="0">
+              <a:buNone/>
+            </a:pPr>
+            <a:r>
+              <a:rPr lang="en-US" sz="1050" dirty="0">
+                <a:solidFill>
+                  <a:srgbClr val="FFFFFF"/>
+                </a:solidFill>
+                <a:latin typeface="Courier New" pitchFamily="34" charset="0"/>
+                <a:ea typeface="Courier New" pitchFamily="34" charset="-122"/>
+                <a:cs typeface="Courier New" pitchFamily="34" charset="-120"/>
+              </a:rPr>
+              <a:t># or manually</a:t>
+            </a:r>
+            <a:endParaRPr lang="en-US" sz="1050" dirty="0"/>
+          </a:p>
+          <a:p>
+            <a:pPr marL="0" indent="0">
+              <a:buNone/>
+            </a:pPr>
+            <a:r>
+              <a:rPr lang="en-US" sz="1050" dirty="0">
+                <a:solidFill>
+                  <a:srgbClr val="FFFFFF"/>
+                </a:solidFill>
+                <a:latin typeface="Courier New" pitchFamily="34" charset="0"/>
+                <a:ea typeface="Courier New" pitchFamily="34" charset="-122"/>
+                <a:cs typeface="Courier New" pitchFamily="34" charset="-120"/>
+              </a:rPr>
+              <a:t>run_llm_server.py --port 50052</a:t>
+            </a:r>
+            <a:endParaRPr lang="en-US" sz="1050" dirty="0"/>
+          </a:p>
+          <a:p>
+            <a:pPr marL="0" indent="0">
+              <a:buNone/>
+            </a:pPr>
+            <a:r>
+              <a:rPr lang="en-US" sz="1050" dirty="0">
+                <a:solidFill>
+                  <a:srgbClr val="FFFFFF"/>
+                </a:solidFill>
+                <a:latin typeface="Courier New" pitchFamily="34" charset="0"/>
+                <a:ea typeface="Courier New" pitchFamily="34" charset="-122"/>
+                <a:cs typeface="Courier New" pitchFamily="34" charset="-120"/>
+              </a:rPr>
+              <a:t>run_server.py --port 50051</a:t>
+            </a:r>
+            <a:endParaRPr lang="en-US" sz="1050" dirty="0"/>
+          </a:p>
+          <a:p>
+            <a:pPr marL="0" indent="0">
+              <a:buNone/>
+            </a:pPr>
+            <a:r>
+              <a:rPr lang="en-US" sz="1050" dirty="0">
+                <a:solidFill>
+                  <a:srgbClr val="FFFFFF"/>
+                </a:solidFill>
+                <a:latin typeface="Courier New" pitchFamily="34" charset="0"/>
+                <a:ea typeface="Courier New" pitchFamily="34" charset="-122"/>
+                <a:cs typeface="Courier New" pitchFamily="34" charset="-120"/>
+              </a:rPr>
+              <a:t>demo_concurrency.py</a:t>
+            </a:r>
+            <a:endParaRPr lang="en-US" sz="1050" dirty="0"/>
+          </a:p>
+        </p:txBody>
+      </p:sp>
+      <p:sp>
+        <p:nvSpPr>
+          <p:cNvPr id="15" name="Shape 13"/>
           <p:cNvSpPr/>
           <p:nvPr/>
         </p:nvSpPr>
         <p:spPr>
           <a:xfrm>
-            <a:off x="3246120" y="1097280"/>
-            <a:ext cx="2651760" cy="1143000"/>
+            <a:off x="4663440" y="1705707"/>
+            <a:ext cx="4023360" cy="2011680"/>
           </a:xfrm>
           <a:prstGeom prst="roundRect">
             <a:avLst>
-              <a:gd name="adj" fmla="val 6400"/>
+              <a:gd name="adj" fmla="val 3636"/>
             </a:avLst>
           </a:prstGeom>
           <a:solidFill>
@@ -9015,77 +8993,38 @@
       </p:sp>
       <p:sp>
         <p:nvSpPr>
-          <p:cNvPr id="7" name="Text 5"/>
-          <p:cNvSpPr txBox="1"/>
-          <p:nvPr/>
-        </p:nvSpPr>
-        <p:spPr>
-          <a:xfrm>
-            <a:off x="3429000" y="1170432"/>
-            <a:ext cx="1371600" cy="731520"/>
-          </a:xfrm>
-          <a:prstGeom prst="rect">
-            <a:avLst/>
-          </a:prstGeom>
-          <a:noFill/>
-          <a:ln/>
-        </p:spPr>
-        <p:txBody>
-          <a:bodyPr wrap="square" lIns="0" tIns="0" rIns="0" bIns="0" rtlCol="0" anchor="ctr"/>
-          <a:lstStyle/>
-          <a:p>
-            <a:pPr indent="0" marL="0">
-              <a:buNone/>
-            </a:pPr>
-            <a:r>
-              <a:rPr lang="en-US" sz="3600" b="1" dirty="0">
+          <p:cNvPr id="16" name="Text 14"/>
+          <p:cNvSpPr txBox="1"/>
+          <p:nvPr/>
+        </p:nvSpPr>
+        <p:spPr>
+          <a:xfrm>
+            <a:off x="4846320" y="1815435"/>
+            <a:ext cx="3657600" cy="228600"/>
+          </a:xfrm>
+          <a:prstGeom prst="rect">
+            <a:avLst/>
+          </a:prstGeom>
+          <a:noFill/>
+          <a:ln/>
+        </p:spPr>
+        <p:txBody>
+          <a:bodyPr wrap="square" lIns="0" tIns="0" rIns="0" bIns="0" rtlCol="0" anchor="t"/>
+          <a:lstStyle/>
+          <a:p>
+            <a:pPr marL="0" indent="0">
+              <a:buNone/>
+            </a:pPr>
+            <a:r>
+              <a:rPr lang="en-US" sz="1100" b="1" dirty="0">
                 <a:solidFill>
                   <a:srgbClr val="F2A541"/>
                 </a:solidFill>
-                <a:latin typeface="Cambria" pitchFamily="34" charset="0"/>
-                <a:ea typeface="Cambria" pitchFamily="34" charset="-122"/>
-                <a:cs typeface="Cambria" pitchFamily="34" charset="-120"/>
-              </a:rPr>
-              <a:t>2</a:t>
-            </a:r>
-            <a:endParaRPr lang="en-US" sz="3600" dirty="0"/>
-          </a:p>
-        </p:txBody>
-      </p:sp>
-      <p:sp>
-        <p:nvSpPr>
-          <p:cNvPr id="8" name="Text 6"/>
-          <p:cNvSpPr txBox="1"/>
-          <p:nvPr/>
-        </p:nvSpPr>
-        <p:spPr>
-          <a:xfrm>
-            <a:off x="4663440" y="1170432"/>
-            <a:ext cx="1143000" cy="731520"/>
-          </a:xfrm>
-          <a:prstGeom prst="rect">
-            <a:avLst/>
-          </a:prstGeom>
-          <a:noFill/>
-          <a:ln/>
-        </p:spPr>
-        <p:txBody>
-          <a:bodyPr wrap="square" lIns="0" tIns="0" rIns="0" bIns="0" rtlCol="0" anchor="ctr"/>
-          <a:lstStyle/>
-          <a:p>
-            <a:pPr indent="0" marL="0">
-              <a:buNone/>
-            </a:pPr>
-            <a:r>
-              <a:rPr lang="en-US" sz="1100" dirty="0">
-                <a:solidFill>
-                  <a:srgbClr val="FFFFFF"/>
-                </a:solidFill>
-                <a:latin typeface="Calibri" pitchFamily="34" charset="0"/>
-                <a:ea typeface="Calibri" pitchFamily="34" charset="-122"/>
-                <a:cs typeface="Calibri" pitchFamily="34" charset="-120"/>
-              </a:rPr>
-              <a:t>gRPC integration tests passing</a:t>
+                <a:latin typeface="Calibri" pitchFamily="34" charset="0"/>
+                <a:ea typeface="Calibri" pitchFamily="34" charset="-122"/>
+                <a:cs typeface="Calibri" pitchFamily="34" charset="-120"/>
+              </a:rPr>
+              <a:t>MILESTONE 2 · DUE 18 NOV</a:t>
             </a:r>
             <a:endParaRPr lang="en-US" sz="1100" dirty="0"/>
           </a:p>
@@ -9093,380 +9032,13 @@
       </p:sp>
       <p:sp>
         <p:nvSpPr>
-          <p:cNvPr id="9" name="Shape 7"/>
-          <p:cNvSpPr/>
-          <p:nvPr/>
-        </p:nvSpPr>
-        <p:spPr>
-          <a:xfrm>
-            <a:off x="6035040" y="1097280"/>
-            <a:ext cx="2651760" cy="1143000"/>
-          </a:xfrm>
-          <a:prstGeom prst="roundRect">
-            <a:avLst>
-              <a:gd name="adj" fmla="val 6400"/>
-            </a:avLst>
-          </a:prstGeom>
-          <a:solidFill>
-            <a:srgbClr val="173F4E"/>
-          </a:solidFill>
-          <a:ln w="12700">
-            <a:solidFill>
-              <a:srgbClr val="173F4E"/>
-            </a:solidFill>
-            <a:prstDash val="solid"/>
-          </a:ln>
-        </p:spPr>
-      </p:sp>
-      <p:sp>
-        <p:nvSpPr>
-          <p:cNvPr id="10" name="Text 8"/>
-          <p:cNvSpPr txBox="1"/>
-          <p:nvPr/>
-        </p:nvSpPr>
-        <p:spPr>
-          <a:xfrm>
-            <a:off x="6217920" y="1170432"/>
-            <a:ext cx="1371600" cy="731520"/>
-          </a:xfrm>
-          <a:prstGeom prst="rect">
-            <a:avLst/>
-          </a:prstGeom>
-          <a:noFill/>
-          <a:ln/>
-        </p:spPr>
-        <p:txBody>
-          <a:bodyPr wrap="square" lIns="0" tIns="0" rIns="0" bIns="0" rtlCol="0" anchor="ctr"/>
-          <a:lstStyle/>
-          <a:p>
-            <a:pPr indent="0" marL="0">
-              <a:buNone/>
-            </a:pPr>
-            <a:r>
-              <a:rPr lang="en-US" sz="3600" b="1" dirty="0">
-                <a:solidFill>
-                  <a:srgbClr val="F2A541"/>
-                </a:solidFill>
-                <a:latin typeface="Cambria" pitchFamily="34" charset="0"/>
-                <a:ea typeface="Cambria" pitchFamily="34" charset="-122"/>
-                <a:cs typeface="Cambria" pitchFamily="34" charset="-120"/>
-              </a:rPr>
-              <a:t>0</a:t>
-            </a:r>
-            <a:endParaRPr lang="en-US" sz="3600" dirty="0"/>
-          </a:p>
-        </p:txBody>
-      </p:sp>
-      <p:sp>
-        <p:nvSpPr>
-          <p:cNvPr id="11" name="Text 9"/>
-          <p:cNvSpPr txBox="1"/>
-          <p:nvPr/>
-        </p:nvSpPr>
-        <p:spPr>
-          <a:xfrm>
-            <a:off x="7452360" y="1170432"/>
-            <a:ext cx="1143000" cy="731520"/>
-          </a:xfrm>
-          <a:prstGeom prst="rect">
-            <a:avLst/>
-          </a:prstGeom>
-          <a:noFill/>
-          <a:ln/>
-        </p:spPr>
-        <p:txBody>
-          <a:bodyPr wrap="square" lIns="0" tIns="0" rIns="0" bIns="0" rtlCol="0" anchor="ctr"/>
-          <a:lstStyle/>
-          <a:p>
-            <a:pPr indent="0" marL="0">
-              <a:buNone/>
-            </a:pPr>
-            <a:r>
-              <a:rPr lang="en-US" sz="1100" dirty="0">
-                <a:solidFill>
-                  <a:srgbClr val="FFFFFF"/>
-                </a:solidFill>
-                <a:latin typeface="Calibri" pitchFamily="34" charset="0"/>
-                <a:ea typeface="Calibri" pitchFamily="34" charset="-122"/>
-                <a:cs typeface="Calibri" pitchFamily="34" charset="-120"/>
-              </a:rPr>
-              <a:t>overbooked in the 10-client race</a:t>
-            </a:r>
-            <a:endParaRPr lang="en-US" sz="1100" dirty="0"/>
-          </a:p>
-        </p:txBody>
-      </p:sp>
-      <p:sp>
-        <p:nvSpPr>
-          <p:cNvPr id="12" name="Shape 10"/>
-          <p:cNvSpPr/>
-          <p:nvPr/>
-        </p:nvSpPr>
-        <p:spPr>
-          <a:xfrm>
-            <a:off x="457200" y="2514600"/>
-            <a:ext cx="4023360" cy="2011680"/>
-          </a:xfrm>
-          <a:prstGeom prst="roundRect">
-            <a:avLst>
-              <a:gd name="adj" fmla="val 3636"/>
-            </a:avLst>
-          </a:prstGeom>
-          <a:solidFill>
-            <a:srgbClr val="173F4E"/>
-          </a:solidFill>
-          <a:ln w="12700">
-            <a:solidFill>
-              <a:srgbClr val="173F4E"/>
-            </a:solidFill>
-            <a:prstDash val="solid"/>
-          </a:ln>
-        </p:spPr>
-      </p:sp>
-      <p:sp>
-        <p:nvSpPr>
-          <p:cNvPr id="13" name="Text 11"/>
-          <p:cNvSpPr txBox="1"/>
-          <p:nvPr/>
-        </p:nvSpPr>
-        <p:spPr>
-          <a:xfrm>
-            <a:off x="640080" y="2624328"/>
-            <a:ext cx="2743200" cy="228600"/>
-          </a:xfrm>
-          <a:prstGeom prst="rect">
-            <a:avLst/>
-          </a:prstGeom>
-          <a:noFill/>
-          <a:ln/>
-        </p:spPr>
-        <p:txBody>
-          <a:bodyPr wrap="square" lIns="0" tIns="0" rIns="0" bIns="0" rtlCol="0" anchor="t"/>
-          <a:lstStyle/>
-          <a:p>
-            <a:pPr indent="0" marL="0">
-              <a:buNone/>
-            </a:pPr>
-            <a:r>
-              <a:rPr lang="en-US" sz="1100" b="1" dirty="0">
-                <a:solidFill>
-                  <a:srgbClr val="F2A541"/>
-                </a:solidFill>
-                <a:latin typeface="Calibri" pitchFamily="34" charset="0"/>
-                <a:ea typeface="Calibri" pitchFamily="34" charset="-122"/>
-                <a:cs typeface="Calibri" pitchFamily="34" charset="-120"/>
-              </a:rPr>
-              <a:t>RUN IT</a:t>
-            </a:r>
-            <a:endParaRPr lang="en-US" sz="1100" dirty="0"/>
-          </a:p>
-        </p:txBody>
-      </p:sp>
-      <p:sp>
-        <p:nvSpPr>
-          <p:cNvPr id="14" name="Text 12"/>
-          <p:cNvSpPr txBox="1"/>
-          <p:nvPr/>
-        </p:nvSpPr>
-        <p:spPr>
-          <a:xfrm>
-            <a:off x="640080" y="2926080"/>
-            <a:ext cx="3657600" cy="1463040"/>
-          </a:xfrm>
-          <a:prstGeom prst="rect">
-            <a:avLst/>
-          </a:prstGeom>
-          <a:noFill/>
-          <a:ln/>
-        </p:spPr>
-        <p:txBody>
-          <a:bodyPr wrap="square" lIns="0" tIns="0" rIns="0" bIns="0" rtlCol="0" anchor="t"/>
-          <a:lstStyle/>
-          <a:p>
-            <a:pPr indent="0" marL="0">
-              <a:buNone/>
-            </a:pPr>
-            <a:r>
-              <a:rPr lang="en-US" sz="1050" dirty="0">
-                <a:solidFill>
-                  <a:srgbClr val="FFFFFF"/>
-                </a:solidFill>
-                <a:latin typeface="Courier New" pitchFamily="34" charset="0"/>
-                <a:ea typeface="Courier New" pitchFamily="34" charset="-122"/>
-                <a:cs typeface="Courier New" pitchFamily="34" charset="-120"/>
-              </a:rPr>
-              <a:t>pip install -e .</a:t>
-            </a:r>
-            <a:endParaRPr lang="en-US" sz="1050" dirty="0"/>
-          </a:p>
-          <a:p>
-            <a:pPr indent="0" marL="0">
-              <a:buNone/>
-            </a:pPr>
-            <a:r>
-              <a:rPr lang="en-US" sz="1050" dirty="0">
-                <a:solidFill>
-                  <a:srgbClr val="FFFFFF"/>
-                </a:solidFill>
-                <a:latin typeface="Courier New" pitchFamily="34" charset="0"/>
-                <a:ea typeface="Courier New" pitchFamily="34" charset="-122"/>
-                <a:cs typeface="Courier New" pitchFamily="34" charset="-120"/>
-              </a:rPr>
-              <a:t>python scripts/run_all_demo.py</a:t>
-            </a:r>
-            <a:endParaRPr lang="en-US" sz="1050" dirty="0"/>
-          </a:p>
-          <a:p>
-            <a:pPr indent="0" marL="0">
-              <a:buNone/>
-            </a:pPr>
-            <a:endParaRPr lang="en-US" sz="1050" dirty="0"/>
-          </a:p>
-          <a:p>
-            <a:pPr indent="0" marL="0">
-              <a:buNone/>
-            </a:pPr>
-            <a:r>
-              <a:rPr lang="en-US" sz="1050" dirty="0">
-                <a:solidFill>
-                  <a:srgbClr val="FFFFFF"/>
-                </a:solidFill>
-                <a:latin typeface="Courier New" pitchFamily="34" charset="0"/>
-                <a:ea typeface="Courier New" pitchFamily="34" charset="-122"/>
-                <a:cs typeface="Courier New" pitchFamily="34" charset="-120"/>
-              </a:rPr>
-              <a:t># or manually</a:t>
-            </a:r>
-            <a:endParaRPr lang="en-US" sz="1050" dirty="0"/>
-          </a:p>
-          <a:p>
-            <a:pPr indent="0" marL="0">
-              <a:buNone/>
-            </a:pPr>
-            <a:r>
-              <a:rPr lang="en-US" sz="1050" dirty="0">
-                <a:solidFill>
-                  <a:srgbClr val="FFFFFF"/>
-                </a:solidFill>
-                <a:latin typeface="Courier New" pitchFamily="34" charset="0"/>
-                <a:ea typeface="Courier New" pitchFamily="34" charset="-122"/>
-                <a:cs typeface="Courier New" pitchFamily="34" charset="-120"/>
-              </a:rPr>
-              <a:t>run_llm_server.py --port 50052</a:t>
-            </a:r>
-            <a:endParaRPr lang="en-US" sz="1050" dirty="0"/>
-          </a:p>
-          <a:p>
-            <a:pPr indent="0" marL="0">
-              <a:buNone/>
-            </a:pPr>
-            <a:r>
-              <a:rPr lang="en-US" sz="1050" dirty="0">
-                <a:solidFill>
-                  <a:srgbClr val="FFFFFF"/>
-                </a:solidFill>
-                <a:latin typeface="Courier New" pitchFamily="34" charset="0"/>
-                <a:ea typeface="Courier New" pitchFamily="34" charset="-122"/>
-                <a:cs typeface="Courier New" pitchFamily="34" charset="-120"/>
-              </a:rPr>
-              <a:t>run_server.py --port 50051</a:t>
-            </a:r>
-            <a:endParaRPr lang="en-US" sz="1050" dirty="0"/>
-          </a:p>
-          <a:p>
-            <a:pPr indent="0" marL="0">
-              <a:buNone/>
-            </a:pPr>
-            <a:r>
-              <a:rPr lang="en-US" sz="1050" dirty="0">
-                <a:solidFill>
-                  <a:srgbClr val="FFFFFF"/>
-                </a:solidFill>
-                <a:latin typeface="Courier New" pitchFamily="34" charset="0"/>
-                <a:ea typeface="Courier New" pitchFamily="34" charset="-122"/>
-                <a:cs typeface="Courier New" pitchFamily="34" charset="-120"/>
-              </a:rPr>
-              <a:t>demo_concurrency.py</a:t>
-            </a:r>
-            <a:endParaRPr lang="en-US" sz="1050" dirty="0"/>
-          </a:p>
-        </p:txBody>
-      </p:sp>
-      <p:sp>
-        <p:nvSpPr>
-          <p:cNvPr id="15" name="Shape 13"/>
-          <p:cNvSpPr/>
-          <p:nvPr/>
-        </p:nvSpPr>
-        <p:spPr>
-          <a:xfrm>
-            <a:off x="4663440" y="2514600"/>
-            <a:ext cx="4023360" cy="2011680"/>
-          </a:xfrm>
-          <a:prstGeom prst="roundRect">
-            <a:avLst>
-              <a:gd name="adj" fmla="val 3636"/>
-            </a:avLst>
-          </a:prstGeom>
-          <a:solidFill>
-            <a:srgbClr val="173F4E"/>
-          </a:solidFill>
-          <a:ln w="12700">
-            <a:solidFill>
-              <a:srgbClr val="173F4E"/>
-            </a:solidFill>
-            <a:prstDash val="solid"/>
-          </a:ln>
-        </p:spPr>
-      </p:sp>
-      <p:sp>
-        <p:nvSpPr>
-          <p:cNvPr id="16" name="Text 14"/>
-          <p:cNvSpPr txBox="1"/>
-          <p:nvPr/>
-        </p:nvSpPr>
-        <p:spPr>
-          <a:xfrm>
-            <a:off x="4846320" y="2624328"/>
-            <a:ext cx="3657600" cy="228600"/>
-          </a:xfrm>
-          <a:prstGeom prst="rect">
-            <a:avLst/>
-          </a:prstGeom>
-          <a:noFill/>
-          <a:ln/>
-        </p:spPr>
-        <p:txBody>
-          <a:bodyPr wrap="square" lIns="0" tIns="0" rIns="0" bIns="0" rtlCol="0" anchor="t"/>
-          <a:lstStyle/>
-          <a:p>
-            <a:pPr indent="0" marL="0">
-              <a:buNone/>
-            </a:pPr>
-            <a:r>
-              <a:rPr lang="en-US" sz="1100" b="1" dirty="0">
-                <a:solidFill>
-                  <a:srgbClr val="F2A541"/>
-                </a:solidFill>
-                <a:latin typeface="Calibri" pitchFamily="34" charset="0"/>
-                <a:ea typeface="Calibri" pitchFamily="34" charset="-122"/>
-                <a:cs typeface="Calibri" pitchFamily="34" charset="-120"/>
-              </a:rPr>
-              <a:t>MILESTONE 2 · DUE 18 NOV</a:t>
-            </a:r>
-            <a:endParaRPr lang="en-US" sz="1100" dirty="0"/>
-          </a:p>
-        </p:txBody>
-      </p:sp>
-      <p:sp>
-        <p:nvSpPr>
           <p:cNvPr id="17" name="Text 15"/>
           <p:cNvSpPr txBox="1"/>
           <p:nvPr/>
         </p:nvSpPr>
         <p:spPr>
           <a:xfrm>
-            <a:off x="4846320" y="2926080"/>
+            <a:off x="4846320" y="2117187"/>
             <a:ext cx="3657600" cy="1463040"/>
           </a:xfrm>
           <a:prstGeom prst="rect">
@@ -9865,4 +9437,299 @@
     </a:ext>
   </a:extLst>
 </a:theme>
+</file>
+
+<file path=ppt/theme/theme2.xml><?xml version="1.0" encoding="utf-8"?>
+<a:theme xmlns:a="http://schemas.openxmlformats.org/drawingml/2006/main" name="Office Theme">
+  <a:themeElements>
+    <a:clrScheme name="Office">
+      <a:dk1>
+        <a:sysClr val="windowText" lastClr="000000"/>
+      </a:dk1>
+      <a:lt1>
+        <a:sysClr val="window" lastClr="FFFFFF"/>
+      </a:lt1>
+      <a:dk2>
+        <a:srgbClr val="44546A"/>
+      </a:dk2>
+      <a:lt2>
+        <a:srgbClr val="E7E6E6"/>
+      </a:lt2>
+      <a:accent1>
+        <a:srgbClr val="4472C4"/>
+      </a:accent1>
+      <a:accent2>
+        <a:srgbClr val="ED7D31"/>
+      </a:accent2>
+      <a:accent3>
+        <a:srgbClr val="A5A5A5"/>
+      </a:accent3>
+      <a:accent4>
+        <a:srgbClr val="FFC000"/>
+      </a:accent4>
+      <a:accent5>
+        <a:srgbClr val="5B9BD5"/>
+      </a:accent5>
+      <a:accent6>
+        <a:srgbClr val="70AD47"/>
+      </a:accent6>
+      <a:hlink>
+        <a:srgbClr val="0563C1"/>
+      </a:hlink>
+      <a:folHlink>
+        <a:srgbClr val="954F72"/>
+      </a:folHlink>
+    </a:clrScheme>
+    <a:fontScheme name="Office">
+      <a:majorFont>
+        <a:latin typeface="Calibri Light" panose="020F0302020204030204"/>
+        <a:ea typeface=""/>
+        <a:cs typeface=""/>
+        <a:font script="Jpan" typeface="游ゴシック Light"/>
+        <a:font script="Hang" typeface="맑은 고딕"/>
+        <a:font script="Hans" typeface="等线 Light"/>
+        <a:font script="Hant" typeface="新細明體"/>
+        <a:font script="Arab" typeface="Times New Roman"/>
+        <a:font script="Hebr" typeface="Times New Roman"/>
+        <a:font script="Thai" typeface="Angsana New"/>
+        <a:font script="Ethi" typeface="Nyala"/>
+        <a:font script="Beng" typeface="Vrinda"/>
+        <a:font script="Gujr" typeface="Shruti"/>
+        <a:font script="Khmr" typeface="MoolBoran"/>
+        <a:font script="Knda" typeface="Tunga"/>
+        <a:font script="Guru" typeface="Raavi"/>
+        <a:font script="Cans" typeface="Euphemia"/>
+        <a:font script="Cher" typeface="Plantagenet Cherokee"/>
+        <a:font script="Yiii" typeface="Microsoft Yi Baiti"/>
+        <a:font script="Tibt" typeface="Microsoft Himalaya"/>
+        <a:font script="Thaa" typeface="MV Boli"/>
+        <a:font script="Deva" typeface="Mangal"/>
+        <a:font script="Telu" typeface="Gautami"/>
+        <a:font script="Taml" typeface="Latha"/>
+        <a:font script="Syrc" typeface="Estrangelo Edessa"/>
+        <a:font script="Orya" typeface="Kalinga"/>
+        <a:font script="Mlym" typeface="Kartika"/>
+        <a:font script="Laoo" typeface="DokChampa"/>
+        <a:font script="Sinh" typeface="Iskoola Pota"/>
+        <a:font script="Mong" typeface="Mongolian Baiti"/>
+        <a:font script="Viet" typeface="Times New Roman"/>
+        <a:font script="Uigh" typeface="Microsoft Uighur"/>
+        <a:font script="Geor" typeface="Sylfaen"/>
+        <a:font script="Armn" typeface="Arial"/>
+        <a:font script="Bugi" typeface="Leelawadee UI"/>
+        <a:font script="Bopo" typeface="Microsoft JhengHei"/>
+        <a:font script="Java" typeface="Javanese Text"/>
+        <a:font script="Lisu" typeface="Segoe UI"/>
+        <a:font script="Mymr" typeface="Myanmar Text"/>
+        <a:font script="Nkoo" typeface="Ebrima"/>
+        <a:font script="Olck" typeface="Nirmala UI"/>
+        <a:font script="Osma" typeface="Ebrima"/>
+        <a:font script="Phag" typeface="Phagspa"/>
+        <a:font script="Syrn" typeface="Estrangelo Edessa"/>
+        <a:font script="Syrj" typeface="Estrangelo Edessa"/>
+        <a:font script="Syre" typeface="Estrangelo Edessa"/>
+        <a:font script="Sora" typeface="Nirmala UI"/>
+        <a:font script="Tale" typeface="Microsoft Tai Le"/>
+        <a:font script="Talu" typeface="Microsoft New Tai Lue"/>
+        <a:font script="Tfng" typeface="Ebrima"/>
+      </a:majorFont>
+      <a:minorFont>
+        <a:latin typeface="Calibri" panose="020F0502020204030204"/>
+        <a:ea typeface=""/>
+        <a:cs typeface=""/>
+        <a:font script="Jpan" typeface="游ゴシック"/>
+        <a:font script="Hang" typeface="맑은 고딕"/>
+        <a:font script="Hans" typeface="等线"/>
+        <a:font script="Hant" typeface="新細明體"/>
+        <a:font script="Arab" typeface="Arial"/>
+        <a:font script="Hebr" typeface="Arial"/>
+        <a:font script="Thai" typeface="Cordia New"/>
+        <a:font script="Ethi" typeface="Nyala"/>
+        <a:font script="Beng" typeface="Vrinda"/>
+        <a:font script="Gujr" typeface="Shruti"/>
+        <a:font script="Khmr" typeface="DaunPenh"/>
+        <a:font script="Knda" typeface="Tunga"/>
+        <a:font script="Guru" typeface="Raavi"/>
+        <a:font script="Cans" typeface="Euphemia"/>
+        <a:font script="Cher" typeface="Plantagenet Cherokee"/>
+        <a:font script="Yiii" typeface="Microsoft Yi Baiti"/>
+        <a:font script="Tibt" typeface="Microsoft Himalaya"/>
+        <a:font script="Thaa" typeface="MV Boli"/>
+        <a:font script="Deva" typeface="Mangal"/>
+        <a:font script="Telu" typeface="Gautami"/>
+        <a:font script="Taml" typeface="Latha"/>
+        <a:font script="Syrc" typeface="Estrangelo Edessa"/>
+        <a:font script="Orya" typeface="Kalinga"/>
+        <a:font script="Mlym" typeface="Kartika"/>
+        <a:font script="Laoo" typeface="DokChampa"/>
+        <a:font script="Sinh" typeface="Iskoola Pota"/>
+        <a:font script="Mong" typeface="Mongolian Baiti"/>
+        <a:font script="Viet" typeface="Arial"/>
+        <a:font script="Uigh" typeface="Microsoft Uighur"/>
+        <a:font script="Geor" typeface="Sylfaen"/>
+        <a:font script="Armn" typeface="Arial"/>
+        <a:font script="Bugi" typeface="Leelawadee UI"/>
+        <a:font script="Bopo" typeface="Microsoft JhengHei"/>
+        <a:font script="Java" typeface="Javanese Text"/>
+        <a:font script="Lisu" typeface="Segoe UI"/>
+        <a:font script="Mymr" typeface="Myanmar Text"/>
+        <a:font script="Nkoo" typeface="Ebrima"/>
+        <a:font script="Olck" typeface="Nirmala UI"/>
+        <a:font script="Osma" typeface="Ebrima"/>
+        <a:font script="Phag" typeface="Phagspa"/>
+        <a:font script="Syrn" typeface="Estrangelo Edessa"/>
+        <a:font script="Syrj" typeface="Estrangelo Edessa"/>
+        <a:font script="Syre" typeface="Estrangelo Edessa"/>
+        <a:font script="Sora" typeface="Nirmala UI"/>
+        <a:font script="Tale" typeface="Microsoft Tai Le"/>
+        <a:font script="Talu" typeface="Microsoft New Tai Lue"/>
+        <a:font script="Tfng" typeface="Ebrima"/>
+      </a:minorFont>
+    </a:fontScheme>
+    <a:fmtScheme name="Office">
+      <a:fillStyleLst>
+        <a:solidFill>
+          <a:schemeClr val="phClr"/>
+        </a:solidFill>
+        <a:gradFill rotWithShape="1">
+          <a:gsLst>
+            <a:gs pos="0">
+              <a:schemeClr val="phClr">
+                <a:lumMod val="110000"/>
+                <a:satMod val="105000"/>
+                <a:tint val="67000"/>
+              </a:schemeClr>
+            </a:gs>
+            <a:gs pos="50000">
+              <a:schemeClr val="phClr">
+                <a:lumMod val="105000"/>
+                <a:satMod val="103000"/>
+                <a:tint val="73000"/>
+              </a:schemeClr>
+            </a:gs>
+            <a:gs pos="100000">
+              <a:schemeClr val="phClr">
+                <a:lumMod val="105000"/>
+                <a:satMod val="109000"/>
+                <a:tint val="81000"/>
+              </a:schemeClr>
+            </a:gs>
+          </a:gsLst>
+          <a:lin ang="5400000" scaled="0"/>
+        </a:gradFill>
+        <a:gradFill rotWithShape="1">
+          <a:gsLst>
+            <a:gs pos="0">
+              <a:schemeClr val="phClr">
+                <a:satMod val="103000"/>
+                <a:lumMod val="102000"/>
+                <a:tint val="94000"/>
+              </a:schemeClr>
+            </a:gs>
+            <a:gs pos="50000">
+              <a:schemeClr val="phClr">
+                <a:satMod val="110000"/>
+                <a:lumMod val="100000"/>
+                <a:shade val="100000"/>
+              </a:schemeClr>
+            </a:gs>
+            <a:gs pos="100000">
+              <a:schemeClr val="phClr">
+                <a:lumMod val="99000"/>
+                <a:satMod val="120000"/>
+                <a:shade val="78000"/>
+              </a:schemeClr>
+            </a:gs>
+          </a:gsLst>
+          <a:lin ang="5400000" scaled="0"/>
+        </a:gradFill>
+      </a:fillStyleLst>
+      <a:lnStyleLst>
+        <a:ln w="6350" cap="flat" cmpd="sng" algn="ctr">
+          <a:solidFill>
+            <a:schemeClr val="phClr"/>
+          </a:solidFill>
+          <a:prstDash val="solid"/>
+          <a:miter lim="800000"/>
+        </a:ln>
+        <a:ln w="12700" cap="flat" cmpd="sng" algn="ctr">
+          <a:solidFill>
+            <a:schemeClr val="phClr"/>
+          </a:solidFill>
+          <a:prstDash val="solid"/>
+          <a:miter lim="800000"/>
+        </a:ln>
+        <a:ln w="19050" cap="flat" cmpd="sng" algn="ctr">
+          <a:solidFill>
+            <a:schemeClr val="phClr"/>
+          </a:solidFill>
+          <a:prstDash val="solid"/>
+          <a:miter lim="800000"/>
+        </a:ln>
+      </a:lnStyleLst>
+      <a:effectStyleLst>
+        <a:effectStyle>
+          <a:effectLst/>
+        </a:effectStyle>
+        <a:effectStyle>
+          <a:effectLst/>
+        </a:effectStyle>
+        <a:effectStyle>
+          <a:effectLst>
+            <a:outerShdw blurRad="57150" dist="19050" dir="5400000" algn="ctr" rotWithShape="0">
+              <a:srgbClr val="000000">
+                <a:alpha val="63000"/>
+              </a:srgbClr>
+            </a:outerShdw>
+          </a:effectLst>
+        </a:effectStyle>
+      </a:effectStyleLst>
+      <a:bgFillStyleLst>
+        <a:solidFill>
+          <a:schemeClr val="phClr"/>
+        </a:solidFill>
+        <a:solidFill>
+          <a:schemeClr val="phClr">
+            <a:tint val="95000"/>
+            <a:satMod val="170000"/>
+          </a:schemeClr>
+        </a:solidFill>
+        <a:gradFill rotWithShape="1">
+          <a:gsLst>
+            <a:gs pos="0">
+              <a:schemeClr val="phClr">
+                <a:tint val="93000"/>
+                <a:satMod val="150000"/>
+                <a:shade val="98000"/>
+                <a:lumMod val="102000"/>
+              </a:schemeClr>
+            </a:gs>
+            <a:gs pos="50000">
+              <a:schemeClr val="phClr">
+                <a:tint val="98000"/>
+                <a:satMod val="130000"/>
+                <a:shade val="90000"/>
+                <a:lumMod val="103000"/>
+              </a:schemeClr>
+            </a:gs>
+            <a:gs pos="100000">
+              <a:schemeClr val="phClr">
+                <a:shade val="63000"/>
+                <a:satMod val="120000"/>
+              </a:schemeClr>
+            </a:gs>
+          </a:gsLst>
+          <a:lin ang="5400000" scaled="0"/>
+        </a:gradFill>
+      </a:bgFillStyleLst>
+    </a:fmtScheme>
+  </a:themeElements>
+  <a:objectDefaults/>
+  <a:extraClrSchemeLst/>
+  <a:extLst>
+    <a:ext uri="{05A4C25C-085E-4340-85A3-A5531E510DB2}">
+      <thm15:themeFamily xmlns:thm15="http://schemas.microsoft.com/office/thememl/2012/main" name="Office Theme" id="{62F939B6-93AF-4DB8-9C6B-D6C7DFDC589F}" vid="{4A3C46E8-61CC-4603-A589-7422A47A8E4A}"/>
+    </a:ext>
+  </a:extLst>
+</a:theme>
 </file>
</xml_diff>